<commit_message>
docs: tighten APAR pitch boundaries
</commit_message>
<xml_diff>
--- a/docs/submission/APAR_COMPETITION_DECK.pptx
+++ b/docs/submission/APAR_COMPETITION_DECK.pptx
@@ -2,23 +2,23 @@
 <file path=ppt/presentation.xml><?xml version="1.0" encoding="utf-8"?>
 <p:presentation xmlns:p="http://schemas.openxmlformats.org/presentationml/2006/main">
   <p:sldMasterIdLst>
-    <p:sldMasterId xmlns:r="http://schemas.openxmlformats.org/officeDocument/2006/relationships" id="2147483648" r:id="R6de035bce60e4c6e"/>
+    <p:sldMasterId xmlns:r="http://schemas.openxmlformats.org/officeDocument/2006/relationships" id="2147483648" r:id="Rba6454fa7361492f"/>
   </p:sldMasterIdLst>
   <p:notesMasterIdLst>
-    <p:notesMasterId xmlns:r="http://schemas.openxmlformats.org/officeDocument/2006/relationships" r:id="R86a577ec95fb4c55"/>
+    <p:notesMasterId xmlns:r="http://schemas.openxmlformats.org/officeDocument/2006/relationships" r:id="R616e4597efa54bc7"/>
   </p:notesMasterIdLst>
   <p:sldIdLst>
-    <p:sldId xmlns:r="http://schemas.openxmlformats.org/officeDocument/2006/relationships" id="256" r:id="R8d378467961b4106"/>
-    <p:sldId xmlns:r="http://schemas.openxmlformats.org/officeDocument/2006/relationships" id="257" r:id="R91221f5c0d7f41a4"/>
-    <p:sldId xmlns:r="http://schemas.openxmlformats.org/officeDocument/2006/relationships" id="258" r:id="R5fe8e43696814853"/>
-    <p:sldId xmlns:r="http://schemas.openxmlformats.org/officeDocument/2006/relationships" id="259" r:id="R32484c3fd1c14f3d"/>
-    <p:sldId xmlns:r="http://schemas.openxmlformats.org/officeDocument/2006/relationships" id="260" r:id="R7905ed7a9aed4077"/>
-    <p:sldId xmlns:r="http://schemas.openxmlformats.org/officeDocument/2006/relationships" id="261" r:id="Raeaa1307aee34239"/>
-    <p:sldId xmlns:r="http://schemas.openxmlformats.org/officeDocument/2006/relationships" id="262" r:id="Rb1fe0839282f4967"/>
-    <p:sldId xmlns:r="http://schemas.openxmlformats.org/officeDocument/2006/relationships" id="263" r:id="R17d87d617202444f"/>
-    <p:sldId xmlns:r="http://schemas.openxmlformats.org/officeDocument/2006/relationships" id="264" r:id="R1a3446fc21484cba"/>
-    <p:sldId xmlns:r="http://schemas.openxmlformats.org/officeDocument/2006/relationships" id="265" r:id="Rf51f319ef10244db"/>
-    <p:sldId xmlns:r="http://schemas.openxmlformats.org/officeDocument/2006/relationships" id="266" r:id="R1ce8f8f696c04e47"/>
+    <p:sldId xmlns:r="http://schemas.openxmlformats.org/officeDocument/2006/relationships" id="256" r:id="Rcc5dc046aff84422"/>
+    <p:sldId xmlns:r="http://schemas.openxmlformats.org/officeDocument/2006/relationships" id="257" r:id="Ra4530839bddd4c6f"/>
+    <p:sldId xmlns:r="http://schemas.openxmlformats.org/officeDocument/2006/relationships" id="258" r:id="R75e3c7e4f0e24c4d"/>
+    <p:sldId xmlns:r="http://schemas.openxmlformats.org/officeDocument/2006/relationships" id="259" r:id="Rf8d78b50ad294077"/>
+    <p:sldId xmlns:r="http://schemas.openxmlformats.org/officeDocument/2006/relationships" id="260" r:id="R6c1bb4882fab4b49"/>
+    <p:sldId xmlns:r="http://schemas.openxmlformats.org/officeDocument/2006/relationships" id="261" r:id="Raea761ffebe548a5"/>
+    <p:sldId xmlns:r="http://schemas.openxmlformats.org/officeDocument/2006/relationships" id="262" r:id="R6516c943ed2144e3"/>
+    <p:sldId xmlns:r="http://schemas.openxmlformats.org/officeDocument/2006/relationships" id="263" r:id="R198f1472d0c14e1d"/>
+    <p:sldId xmlns:r="http://schemas.openxmlformats.org/officeDocument/2006/relationships" id="264" r:id="R770b6b60b5f04055"/>
+    <p:sldId xmlns:r="http://schemas.openxmlformats.org/officeDocument/2006/relationships" id="265" r:id="Rb81bbb8cce544422"/>
+    <p:sldId xmlns:r="http://schemas.openxmlformats.org/officeDocument/2006/relationships" id="266" r:id="R8390095142e648c7"/>
   </p:sldIdLst>
   <p:sldSz cx="12192000" cy="6858000"/>
   <p:notesSz cx="6858000" cy="9144000"/>
@@ -1422,7 +1422,7 @@
           <a:lstStyle xmlns:a="http://schemas.openxmlformats.org/drawingml/2006/main"/>
           <a:p xmlns:a="http://schemas.openxmlformats.org/drawingml/2006/main">
             <a:r>
-              <a:t>Show that honest incompleteness is visible. The official chain is incomplete at Stage 70; recovered metrics remain diagnostics.</a:t>
+              <a:t>Show that every evidence step stays auditable and that promotion remains a human decision; recovered metrics remain diagnostics.</a:t>
             </a:r>
           </a:p>
           <a:p xmlns:a="http://schemas.openxmlformats.org/drawingml/2006/main">
@@ -1520,7 +1520,7 @@
   </p:cSld>
   <p:clrMap bg1="lt1" tx1="dk1" bg2="lt2" tx2="dk2" accent1="accent1" accent2="accent2" accent3="accent3" accent4="accent4" accent5="accent5" accent6="accent6" hlink="hlink" folHlink="folHlink"/>
   <p:sldLayoutIdLst>
-    <p:sldLayoutId xmlns:r="http://schemas.openxmlformats.org/officeDocument/2006/relationships" id="2147483649" r:id="R15cd6fcb91ad4273"/>
+    <p:sldLayoutId xmlns:r="http://schemas.openxmlformats.org/officeDocument/2006/relationships" id="2147483649" r:id="Rebf98c5742074211"/>
   </p:sldLayoutIdLst>
   <p:txStyles>
     <p:titleStyle>
@@ -2464,8 +2464,8 @@
           <p:nvPr/>
         </p:nvPicPr>
         <p:blipFill>
-          <a:blip xmlns:r="http://schemas.openxmlformats.org/officeDocument/2006/relationships" xmlns:a="http://schemas.openxmlformats.org/drawingml/2006/main" r:embed="Rc6105b72098c4972"/>
-          <a:srcRect xmlns:a="http://schemas.openxmlformats.org/drawingml/2006/main" l="0" t="16347" r="0" b="16347"/>
+          <a:blip xmlns:r="http://schemas.openxmlformats.org/officeDocument/2006/relationships" xmlns:a="http://schemas.openxmlformats.org/drawingml/2006/main" r:embed="Re414f4f5e37f4a99"/>
+          <a:srcRect xmlns:a="http://schemas.openxmlformats.org/drawingml/2006/main" l="0" t="0" r="0" b="32694"/>
           <a:stretch xmlns:a="http://schemas.openxmlformats.org/drawingml/2006/main">
             <a:fillRect l="0" t="0" r="0" b="0"/>
           </a:stretch>
@@ -2937,7 +2937,7 @@
         </p:spPr>
         <p:txBody>
           <a:bodyPr xmlns:a="http://schemas.openxmlformats.org/drawingml/2006/main" anchor="t">
-            <a:normAutofit fontScale="67315"/>
+            <a:normAutofit fontScale="67321"/>
           </a:bodyPr>
           <a:lstStyle xmlns:a="http://schemas.openxmlformats.org/drawingml/2006/main"/>
           <a:p xmlns:a="http://schemas.openxmlformats.org/drawingml/2006/main">
@@ -3055,7 +3055,7 @@
         </p:spPr>
         <p:txBody>
           <a:bodyPr xmlns:a="http://schemas.openxmlformats.org/drawingml/2006/main" anchor="t">
-            <a:normAutofit fontScale="67315"/>
+            <a:normAutofit fontScale="67321"/>
           </a:bodyPr>
           <a:lstStyle xmlns:a="http://schemas.openxmlformats.org/drawingml/2006/main"/>
           <a:p xmlns:a="http://schemas.openxmlformats.org/drawingml/2006/main">
@@ -3173,7 +3173,7 @@
         </p:spPr>
         <p:txBody>
           <a:bodyPr xmlns:a="http://schemas.openxmlformats.org/drawingml/2006/main" anchor="t">
-            <a:normAutofit fontScale="67315"/>
+            <a:normAutofit fontScale="67321"/>
           </a:bodyPr>
           <a:lstStyle xmlns:a="http://schemas.openxmlformats.org/drawingml/2006/main"/>
           <a:p xmlns:a="http://schemas.openxmlformats.org/drawingml/2006/main">
@@ -3291,7 +3291,7 @@
         </p:spPr>
         <p:txBody>
           <a:bodyPr xmlns:a="http://schemas.openxmlformats.org/drawingml/2006/main" anchor="t">
-            <a:normAutofit fontScale="67315"/>
+            <a:normAutofit fontScale="67321"/>
           </a:bodyPr>
           <a:lstStyle xmlns:a="http://schemas.openxmlformats.org/drawingml/2006/main"/>
           <a:p xmlns:a="http://schemas.openxmlformats.org/drawingml/2006/main">
@@ -3409,7 +3409,7 @@
         </p:spPr>
         <p:txBody>
           <a:bodyPr xmlns:a="http://schemas.openxmlformats.org/drawingml/2006/main" anchor="t">
-            <a:normAutofit fontScale="67315"/>
+            <a:normAutofit fontScale="67321"/>
           </a:bodyPr>
           <a:lstStyle xmlns:a="http://schemas.openxmlformats.org/drawingml/2006/main"/>
           <a:p xmlns:a="http://schemas.openxmlformats.org/drawingml/2006/main">
@@ -3728,7 +3728,7 @@
                 <a:ea typeface="Arial"/>
                 <a:cs typeface="Arial"/>
               </a:rPr>
-              <a:t>Accepted official Stage 70 capacity evidence</a:t>
+              <a:t>Production-readiness or scale evidence</a:t>
             </a:r>
           </a:p>
         </p:txBody>
@@ -4082,7 +4082,7 @@
                 <a:ea typeface="Arial"/>
                 <a:cs typeface="Arial"/>
               </a:rPr>
-              <a:t>Full Sentinel as the champion</a:t>
+              <a:t>Claims beyond the demonstrated model</a:t>
             </a:r>
           </a:p>
         </p:txBody>
@@ -14548,7 +14548,7 @@
           <p:nvPr/>
         </p:nvPicPr>
         <p:blipFill>
-          <a:blip xmlns:r="http://schemas.openxmlformats.org/officeDocument/2006/relationships" xmlns:a="http://schemas.openxmlformats.org/drawingml/2006/main" r:embed="R707547b1984b4bfd"/>
+          <a:blip xmlns:r="http://schemas.openxmlformats.org/officeDocument/2006/relationships" xmlns:a="http://schemas.openxmlformats.org/drawingml/2006/main" r:embed="Rdcd35cd688844fb5"/>
           <a:srcRect xmlns:a="http://schemas.openxmlformats.org/drawingml/2006/main" l="0" t="33403" r="0" b="33403"/>
           <a:stretch xmlns:a="http://schemas.openxmlformats.org/drawingml/2006/main">
             <a:fillRect l="0" t="0" r="0" b="0"/>
@@ -15518,7 +15518,7 @@
           <p:nvPr/>
         </p:nvPicPr>
         <p:blipFill>
-          <a:blip xmlns:r="http://schemas.openxmlformats.org/officeDocument/2006/relationships" xmlns:a="http://schemas.openxmlformats.org/drawingml/2006/main" r:embed="Rb5aa5534c50c4074"/>
+          <a:blip xmlns:r="http://schemas.openxmlformats.org/officeDocument/2006/relationships" xmlns:a="http://schemas.openxmlformats.org/drawingml/2006/main" r:embed="R790a8475524543bd"/>
           <a:srcRect xmlns:a="http://schemas.openxmlformats.org/drawingml/2006/main" l="0" t="29622" r="0" b="29622"/>
           <a:stretch xmlns:a="http://schemas.openxmlformats.org/drawingml/2006/main">
             <a:fillRect l="0" t="0" r="0" b="0"/>
@@ -16359,8 +16359,8 @@
           <p:nvPr/>
         </p:nvPicPr>
         <p:blipFill>
-          <a:blip xmlns:r="http://schemas.openxmlformats.org/officeDocument/2006/relationships" xmlns:a="http://schemas.openxmlformats.org/drawingml/2006/main" r:embed="R8421a73664704653"/>
-          <a:srcRect xmlns:a="http://schemas.openxmlformats.org/drawingml/2006/main" l="0" t="38568" r="0" b="38568"/>
+          <a:blip xmlns:r="http://schemas.openxmlformats.org/officeDocument/2006/relationships" xmlns:a="http://schemas.openxmlformats.org/drawingml/2006/main" r:embed="R722bcae7e1fe4f3f"/>
+          <a:srcRect xmlns:a="http://schemas.openxmlformats.org/drawingml/2006/main" l="0" t="46500" r="0" b="30636"/>
           <a:stretch xmlns:a="http://schemas.openxmlformats.org/drawingml/2006/main">
             <a:fillRect l="0" t="0" r="0" b="0"/>
           </a:stretch>
@@ -19115,7 +19115,7 @@
                 <a:ea typeface="Menlo"/>
                 <a:cs typeface="Menlo"/>
               </a:rPr>
-              <a:t>Official chain</a:t>
+              <a:t>Promotion boundary</a:t>
             </a:r>
           </a:p>
         </p:txBody>
@@ -19174,7 +19174,7 @@
                 <a:ea typeface="Menlo"/>
                 <a:cs typeface="Menlo"/>
               </a:rPr>
-              <a:t>Stops at Stage 60</a:t>
+              <a:t>Human approval required</a:t>
             </a:r>
           </a:p>
         </p:txBody>
@@ -19268,7 +19268,7 @@
                 <a:ea typeface="Menlo"/>
                 <a:cs typeface="Menlo"/>
               </a:rPr>
-              <a:t>STAGE 70 NOT CLAIMED</a:t>
+              <a:t>NO SELF-PROMOTION</a:t>
             </a:r>
           </a:p>
         </p:txBody>

</xml_diff>

<commit_message>
design: refine key evidence cards
</commit_message>
<xml_diff>
--- a/docs/submission/APAR_COMPETITION_DECK.pptx
+++ b/docs/submission/APAR_COMPETITION_DECK.pptx
@@ -2,23 +2,23 @@
 <file path=ppt/presentation.xml><?xml version="1.0" encoding="utf-8"?>
 <p:presentation xmlns:p="http://schemas.openxmlformats.org/presentationml/2006/main">
   <p:sldMasterIdLst>
-    <p:sldMasterId xmlns:r="http://schemas.openxmlformats.org/officeDocument/2006/relationships" id="2147483648" r:id="R0596405537454097"/>
+    <p:sldMasterId xmlns:r="http://schemas.openxmlformats.org/officeDocument/2006/relationships" id="2147483648" r:id="R2cd3fc62273843aa"/>
   </p:sldMasterIdLst>
   <p:notesMasterIdLst>
-    <p:notesMasterId xmlns:r="http://schemas.openxmlformats.org/officeDocument/2006/relationships" r:id="R570b005f04ee40a5"/>
+    <p:notesMasterId xmlns:r="http://schemas.openxmlformats.org/officeDocument/2006/relationships" r:id="R351acfcfe1dd4b83"/>
   </p:notesMasterIdLst>
   <p:sldIdLst>
-    <p:sldId xmlns:r="http://schemas.openxmlformats.org/officeDocument/2006/relationships" id="256" r:id="R0b56787107de4416"/>
-    <p:sldId xmlns:r="http://schemas.openxmlformats.org/officeDocument/2006/relationships" id="257" r:id="R4554b7a691e84368"/>
-    <p:sldId xmlns:r="http://schemas.openxmlformats.org/officeDocument/2006/relationships" id="258" r:id="Rb6d7cb6c690547a3"/>
-    <p:sldId xmlns:r="http://schemas.openxmlformats.org/officeDocument/2006/relationships" id="259" r:id="R63140776d4e54952"/>
-    <p:sldId xmlns:r="http://schemas.openxmlformats.org/officeDocument/2006/relationships" id="260" r:id="R5569c5c73a0c46ae"/>
-    <p:sldId xmlns:r="http://schemas.openxmlformats.org/officeDocument/2006/relationships" id="261" r:id="Rd1b5af351b064233"/>
-    <p:sldId xmlns:r="http://schemas.openxmlformats.org/officeDocument/2006/relationships" id="262" r:id="R56b4491126e74e72"/>
-    <p:sldId xmlns:r="http://schemas.openxmlformats.org/officeDocument/2006/relationships" id="263" r:id="Rbd26517a9da54114"/>
-    <p:sldId xmlns:r="http://schemas.openxmlformats.org/officeDocument/2006/relationships" id="264" r:id="R2cc1af7360124e34"/>
-    <p:sldId xmlns:r="http://schemas.openxmlformats.org/officeDocument/2006/relationships" id="265" r:id="Rae3fe964d4264616"/>
-    <p:sldId xmlns:r="http://schemas.openxmlformats.org/officeDocument/2006/relationships" id="266" r:id="Rd5a62c8f8af243cf"/>
+    <p:sldId xmlns:r="http://schemas.openxmlformats.org/officeDocument/2006/relationships" id="256" r:id="R2b30af6436884418"/>
+    <p:sldId xmlns:r="http://schemas.openxmlformats.org/officeDocument/2006/relationships" id="257" r:id="R04449302b2814ddb"/>
+    <p:sldId xmlns:r="http://schemas.openxmlformats.org/officeDocument/2006/relationships" id="258" r:id="R5c5fdd481cea4cbb"/>
+    <p:sldId xmlns:r="http://schemas.openxmlformats.org/officeDocument/2006/relationships" id="259" r:id="R7e85c67bfd3f4de6"/>
+    <p:sldId xmlns:r="http://schemas.openxmlformats.org/officeDocument/2006/relationships" id="260" r:id="R285a23eb0a3247cb"/>
+    <p:sldId xmlns:r="http://schemas.openxmlformats.org/officeDocument/2006/relationships" id="261" r:id="R66a2c03cd2064ed9"/>
+    <p:sldId xmlns:r="http://schemas.openxmlformats.org/officeDocument/2006/relationships" id="262" r:id="Rfee801a008154497"/>
+    <p:sldId xmlns:r="http://schemas.openxmlformats.org/officeDocument/2006/relationships" id="263" r:id="R43c3ef3f1ca245e1"/>
+    <p:sldId xmlns:r="http://schemas.openxmlformats.org/officeDocument/2006/relationships" id="264" r:id="R54b352b5718348c4"/>
+    <p:sldId xmlns:r="http://schemas.openxmlformats.org/officeDocument/2006/relationships" id="265" r:id="Re0e413e67d954abc"/>
+    <p:sldId xmlns:r="http://schemas.openxmlformats.org/officeDocument/2006/relationships" id="266" r:id="R18b2effe0dd942f9"/>
   </p:sldIdLst>
   <p:sldSz cx="12192000" cy="6858000"/>
   <p:notesSz cx="6858000" cy="9144000"/>
@@ -1520,7 +1520,7 @@
   </p:cSld>
   <p:clrMap bg1="lt1" tx1="dk1" bg2="lt2" tx2="dk2" accent1="accent1" accent2="accent2" accent3="accent3" accent4="accent4" accent5="accent5" accent6="accent6" hlink="hlink" folHlink="folHlink"/>
   <p:sldLayoutIdLst>
-    <p:sldLayoutId xmlns:r="http://schemas.openxmlformats.org/officeDocument/2006/relationships" id="2147483649" r:id="R3c7dbd5bbff44069"/>
+    <p:sldLayoutId xmlns:r="http://schemas.openxmlformats.org/officeDocument/2006/relationships" id="2147483649" r:id="R4a9adf1f0f19459a"/>
   </p:sldLayoutIdLst>
   <p:txStyles>
     <p:titleStyle>
@@ -2462,7 +2462,7 @@
           <p:nvPr/>
         </p:nvPicPr>
         <p:blipFill>
-          <a:blip xmlns:r="http://schemas.openxmlformats.org/officeDocument/2006/relationships" xmlns:a="http://schemas.openxmlformats.org/drawingml/2006/main" r:embed="Raf2ed721ac014bee"/>
+          <a:blip xmlns:r="http://schemas.openxmlformats.org/officeDocument/2006/relationships" xmlns:a="http://schemas.openxmlformats.org/drawingml/2006/main" r:embed="Rfb0c5d05412a474f"/>
           <a:srcRect xmlns:a="http://schemas.openxmlformats.org/drawingml/2006/main" l="0" t="0" r="0" b="32694"/>
           <a:stretch xmlns:a="http://schemas.openxmlformats.org/drawingml/2006/main">
             <a:fillRect l="0" t="0" r="0" b="0"/>
@@ -4400,17 +4400,15 @@
         <p:spPr>
           <a:xfrm xmlns:a="http://schemas.openxmlformats.org/drawingml/2006/main">
             <a:off x="400050" y="1752600"/>
-            <a:ext cx="2019300" cy="28575"/>
+            <a:ext cx="2019300" cy="2076450"/>
           </a:xfrm>
           <a:prstGeom xmlns:a="http://schemas.openxmlformats.org/drawingml/2006/main" prst="roundRect">
             <a:avLst>
-              <a:gd name="adj" fmla="val 5660"/>
+              <a:gd name="adj" fmla="val 0"/>
             </a:avLst>
           </a:prstGeom>
-          <a:solidFill xmlns:a="http://schemas.openxmlformats.org/drawingml/2006/main">
-            <a:srgbClr val="E8793D"/>
-          </a:solidFill>
-          <a:ln xmlns:a="http://schemas.openxmlformats.org/drawingml/2006/main" w="0">
+          <a:noFill xmlns:a="http://schemas.openxmlformats.org/drawingml/2006/main"/>
+          <a:ln xmlns:a="http://schemas.openxmlformats.org/drawingml/2006/main" w="11430">
             <a:solidFill>
               <a:srgbClr val="E8793D"/>
             </a:solidFill>
@@ -4448,7 +4446,7 @@
         </p:spPr>
         <p:txBody>
           <a:bodyPr xmlns:a="http://schemas.openxmlformats.org/drawingml/2006/main" anchor="t">
-            <a:normAutofit fontScale="80702"/>
+            <a:normAutofit fontScale="76667"/>
           </a:bodyPr>
           <a:lstStyle xmlns:a="http://schemas.openxmlformats.org/drawingml/2006/main"/>
           <a:p xmlns:a="http://schemas.openxmlformats.org/drawingml/2006/main">
@@ -4464,7 +4462,7 @@
               </a:defRPr>
             </a:pPr>
             <a:r>
-              <a:rPr sz="1425" b="0">
+              <a:rPr sz="1500" b="0">
                 <a:solidFill>
                   <a:srgbClr val="F19A68"/>
                 </a:solidFill>
@@ -4671,19 +4669,17 @@
         <p:spPr>
           <a:xfrm xmlns:a="http://schemas.openxmlformats.org/drawingml/2006/main">
             <a:off x="2667000" y="1752600"/>
-            <a:ext cx="2019300" cy="9525"/>
+            <a:ext cx="2019300" cy="2076450"/>
           </a:xfrm>
           <a:prstGeom xmlns:a="http://schemas.openxmlformats.org/drawingml/2006/main" prst="roundRect">
             <a:avLst>
-              <a:gd name="adj" fmla="val 5660"/>
+              <a:gd name="adj" fmla="val 0"/>
             </a:avLst>
           </a:prstGeom>
-          <a:solidFill xmlns:a="http://schemas.openxmlformats.org/drawingml/2006/main">
-            <a:srgbClr val="6B5F50"/>
-          </a:solidFill>
-          <a:ln xmlns:a="http://schemas.openxmlformats.org/drawingml/2006/main" w="0">
+          <a:noFill xmlns:a="http://schemas.openxmlformats.org/drawingml/2006/main"/>
+          <a:ln xmlns:a="http://schemas.openxmlformats.org/drawingml/2006/main" w="7620">
             <a:solidFill>
-              <a:srgbClr val="6B5F50"/>
+              <a:srgbClr val="3F382E"/>
             </a:solidFill>
             <a:prstDash val="solid"/>
           </a:ln>
@@ -4719,7 +4715,7 @@
         </p:spPr>
         <p:txBody>
           <a:bodyPr xmlns:a="http://schemas.openxmlformats.org/drawingml/2006/main" anchor="t">
-            <a:normAutofit fontScale="80702"/>
+            <a:normAutofit fontScale="76667"/>
           </a:bodyPr>
           <a:lstStyle xmlns:a="http://schemas.openxmlformats.org/drawingml/2006/main"/>
           <a:p xmlns:a="http://schemas.openxmlformats.org/drawingml/2006/main">
@@ -4735,7 +4731,7 @@
               </a:defRPr>
             </a:pPr>
             <a:r>
-              <a:rPr sz="1425" b="0">
+              <a:rPr sz="1500" b="0">
                 <a:solidFill>
                   <a:srgbClr val="F19A68"/>
                 </a:solidFill>
@@ -4942,19 +4938,17 @@
         <p:spPr>
           <a:xfrm xmlns:a="http://schemas.openxmlformats.org/drawingml/2006/main">
             <a:off x="4933950" y="1752600"/>
-            <a:ext cx="2019300" cy="9525"/>
+            <a:ext cx="2019300" cy="2076450"/>
           </a:xfrm>
           <a:prstGeom xmlns:a="http://schemas.openxmlformats.org/drawingml/2006/main" prst="roundRect">
             <a:avLst>
-              <a:gd name="adj" fmla="val 5660"/>
+              <a:gd name="adj" fmla="val 0"/>
             </a:avLst>
           </a:prstGeom>
-          <a:solidFill xmlns:a="http://schemas.openxmlformats.org/drawingml/2006/main">
-            <a:srgbClr val="6B5F50"/>
-          </a:solidFill>
-          <a:ln xmlns:a="http://schemas.openxmlformats.org/drawingml/2006/main" w="0">
+          <a:noFill xmlns:a="http://schemas.openxmlformats.org/drawingml/2006/main"/>
+          <a:ln xmlns:a="http://schemas.openxmlformats.org/drawingml/2006/main" w="7620">
             <a:solidFill>
-              <a:srgbClr val="6B5F50"/>
+              <a:srgbClr val="3F382E"/>
             </a:solidFill>
             <a:prstDash val="solid"/>
           </a:ln>
@@ -4990,7 +4984,7 @@
         </p:spPr>
         <p:txBody>
           <a:bodyPr xmlns:a="http://schemas.openxmlformats.org/drawingml/2006/main" anchor="t">
-            <a:normAutofit fontScale="80702"/>
+            <a:normAutofit fontScale="76667"/>
           </a:bodyPr>
           <a:lstStyle xmlns:a="http://schemas.openxmlformats.org/drawingml/2006/main"/>
           <a:p xmlns:a="http://schemas.openxmlformats.org/drawingml/2006/main">
@@ -5006,7 +5000,7 @@
               </a:defRPr>
             </a:pPr>
             <a:r>
-              <a:rPr sz="1425" b="0">
+              <a:rPr sz="1500" b="0">
                 <a:solidFill>
                   <a:srgbClr val="F19A68"/>
                 </a:solidFill>
@@ -5213,19 +5207,17 @@
         <p:spPr>
           <a:xfrm xmlns:a="http://schemas.openxmlformats.org/drawingml/2006/main">
             <a:off x="7200900" y="1752600"/>
-            <a:ext cx="2019300" cy="9525"/>
+            <a:ext cx="2019300" cy="2076450"/>
           </a:xfrm>
           <a:prstGeom xmlns:a="http://schemas.openxmlformats.org/drawingml/2006/main" prst="roundRect">
             <a:avLst>
-              <a:gd name="adj" fmla="val 5660"/>
+              <a:gd name="adj" fmla="val 0"/>
             </a:avLst>
           </a:prstGeom>
-          <a:solidFill xmlns:a="http://schemas.openxmlformats.org/drawingml/2006/main">
-            <a:srgbClr val="6B5F50"/>
-          </a:solidFill>
-          <a:ln xmlns:a="http://schemas.openxmlformats.org/drawingml/2006/main" w="0">
+          <a:noFill xmlns:a="http://schemas.openxmlformats.org/drawingml/2006/main"/>
+          <a:ln xmlns:a="http://schemas.openxmlformats.org/drawingml/2006/main" w="7620">
             <a:solidFill>
-              <a:srgbClr val="6B5F50"/>
+              <a:srgbClr val="3F382E"/>
             </a:solidFill>
             <a:prstDash val="solid"/>
           </a:ln>
@@ -5261,7 +5253,7 @@
         </p:spPr>
         <p:txBody>
           <a:bodyPr xmlns:a="http://schemas.openxmlformats.org/drawingml/2006/main" anchor="t">
-            <a:normAutofit fontScale="80702"/>
+            <a:normAutofit fontScale="76667"/>
           </a:bodyPr>
           <a:lstStyle xmlns:a="http://schemas.openxmlformats.org/drawingml/2006/main"/>
           <a:p xmlns:a="http://schemas.openxmlformats.org/drawingml/2006/main">
@@ -5277,7 +5269,7 @@
               </a:defRPr>
             </a:pPr>
             <a:r>
-              <a:rPr sz="1425" b="0">
+              <a:rPr sz="1500" b="0">
                 <a:solidFill>
                   <a:srgbClr val="F19A68"/>
                 </a:solidFill>
@@ -5484,19 +5476,17 @@
         <p:spPr>
           <a:xfrm xmlns:a="http://schemas.openxmlformats.org/drawingml/2006/main">
             <a:off x="9467850" y="1752600"/>
-            <a:ext cx="2019300" cy="9525"/>
+            <a:ext cx="2019300" cy="2076450"/>
           </a:xfrm>
           <a:prstGeom xmlns:a="http://schemas.openxmlformats.org/drawingml/2006/main" prst="roundRect">
             <a:avLst>
-              <a:gd name="adj" fmla="val 5660"/>
+              <a:gd name="adj" fmla="val 0"/>
             </a:avLst>
           </a:prstGeom>
-          <a:solidFill xmlns:a="http://schemas.openxmlformats.org/drawingml/2006/main">
-            <a:srgbClr val="6B5F50"/>
-          </a:solidFill>
-          <a:ln xmlns:a="http://schemas.openxmlformats.org/drawingml/2006/main" w="0">
+          <a:noFill xmlns:a="http://schemas.openxmlformats.org/drawingml/2006/main"/>
+          <a:ln xmlns:a="http://schemas.openxmlformats.org/drawingml/2006/main" w="11430">
             <a:solidFill>
-              <a:srgbClr val="6B5F50"/>
+              <a:srgbClr val="75B78E"/>
             </a:solidFill>
             <a:prstDash val="solid"/>
           </a:ln>
@@ -5532,7 +5522,7 @@
         </p:spPr>
         <p:txBody>
           <a:bodyPr xmlns:a="http://schemas.openxmlformats.org/drawingml/2006/main" anchor="t">
-            <a:normAutofit fontScale="80702"/>
+            <a:normAutofit fontScale="76667"/>
           </a:bodyPr>
           <a:lstStyle xmlns:a="http://schemas.openxmlformats.org/drawingml/2006/main"/>
           <a:p xmlns:a="http://schemas.openxmlformats.org/drawingml/2006/main">
@@ -5548,9 +5538,9 @@
               </a:defRPr>
             </a:pPr>
             <a:r>
-              <a:rPr sz="1425" b="0">
-                <a:solidFill>
-                  <a:srgbClr val="F19A68"/>
+              <a:rPr sz="1500" b="0">
+                <a:solidFill>
+                  <a:srgbClr val="75B78E"/>
                 </a:solidFill>
                 <a:latin typeface="Georgia"/>
                 <a:ea typeface="Georgia"/>
@@ -6170,21 +6160,21 @@
         </p:nvSpPr>
         <p:spPr>
           <a:xfrm xmlns:a="http://schemas.openxmlformats.org/drawingml/2006/main">
-            <a:off x="11277600" y="1752600"/>
-            <a:ext cx="514350" cy="285750"/>
-          </a:xfrm>
-          <a:prstGeom xmlns:a="http://schemas.openxmlformats.org/drawingml/2006/main" prst="rect">
-            <a:avLst/>
-          </a:prstGeom>
-          <a:noFill xmlns:a="http://schemas.openxmlformats.org/drawingml/2006/main"/>
-          <a:ln xmlns:a="http://schemas.openxmlformats.org/drawingml/2006/main" w="0">
-            <a:noFill/>
-            <a:prstDash val="solid"/>
-          </a:ln>
-        </p:spPr>
-        <p:txBody>
-          <a:bodyPr xmlns:a="http://schemas.openxmlformats.org/drawingml/2006/main" anchor="t">
-            <a:normAutofit fontScale="85000"/>
+            <a:off x="11277600" y="342900"/>
+            <a:ext cx="514350" cy="209550"/>
+          </a:xfrm>
+          <a:prstGeom xmlns:a="http://schemas.openxmlformats.org/drawingml/2006/main" prst="rect">
+            <a:avLst/>
+          </a:prstGeom>
+          <a:noFill xmlns:a="http://schemas.openxmlformats.org/drawingml/2006/main"/>
+          <a:ln xmlns:a="http://schemas.openxmlformats.org/drawingml/2006/main" w="0">
+            <a:noFill/>
+            <a:prstDash val="solid"/>
+          </a:ln>
+        </p:spPr>
+        <p:txBody>
+          <a:bodyPr xmlns:a="http://schemas.openxmlformats.org/drawingml/2006/main" anchor="t">
+            <a:normAutofit fontScale="93939"/>
           </a:bodyPr>
           <a:lstStyle xmlns:a="http://schemas.openxmlformats.org/drawingml/2006/main"/>
           <a:p xmlns:a="http://schemas.openxmlformats.org/drawingml/2006/main">
@@ -6200,13 +6190,13 @@
               </a:defRPr>
             </a:pPr>
             <a:r>
-              <a:rPr sz="1500" b="0">
-                <a:solidFill>
-                  <a:srgbClr val="F19A68"/>
-                </a:solidFill>
-                <a:latin typeface="Georgia"/>
-                <a:ea typeface="Georgia"/>
-                <a:cs typeface="Georgia"/>
+              <a:rPr sz="825" b="0">
+                <a:solidFill>
+                  <a:srgbClr val="9C9183"/>
+                </a:solidFill>
+                <a:latin typeface="Menlo"/>
+                <a:ea typeface="Menlo"/>
+                <a:cs typeface="Menlo"/>
               </a:rPr>
               <a:t>02</a:t>
             </a:r>
@@ -14494,7 +14484,7 @@
           <p:nvPr/>
         </p:nvPicPr>
         <p:blipFill>
-          <a:blip xmlns:r="http://schemas.openxmlformats.org/officeDocument/2006/relationships" xmlns:a="http://schemas.openxmlformats.org/drawingml/2006/main" r:embed="Re7b93f326ffa4926"/>
+          <a:blip xmlns:r="http://schemas.openxmlformats.org/officeDocument/2006/relationships" xmlns:a="http://schemas.openxmlformats.org/drawingml/2006/main" r:embed="Re775445b32fb4eb8"/>
           <a:srcRect xmlns:a="http://schemas.openxmlformats.org/drawingml/2006/main" l="0" t="33403" r="0" b="33403"/>
           <a:stretch xmlns:a="http://schemas.openxmlformats.org/drawingml/2006/main">
             <a:fillRect l="0" t="0" r="0" b="0"/>
@@ -15441,7 +15431,7 @@
           </a:xfrm>
           <a:prstGeom xmlns:a="http://schemas.openxmlformats.org/drawingml/2006/main" prst="roundRect">
             <a:avLst>
-              <a:gd name="adj" fmla="val 2429"/>
+              <a:gd name="adj" fmla="val 0"/>
             </a:avLst>
           </a:prstGeom>
           <a:noFill xmlns:a="http://schemas.openxmlformats.org/drawingml/2006/main"/>
@@ -15462,7 +15452,7 @@
           <p:nvPr/>
         </p:nvPicPr>
         <p:blipFill>
-          <a:blip xmlns:r="http://schemas.openxmlformats.org/officeDocument/2006/relationships" xmlns:a="http://schemas.openxmlformats.org/drawingml/2006/main" r:embed="R9fd001e6212042d1"/>
+          <a:blip xmlns:r="http://schemas.openxmlformats.org/officeDocument/2006/relationships" xmlns:a="http://schemas.openxmlformats.org/drawingml/2006/main" r:embed="Rffb087988b9f4222"/>
           <a:srcRect xmlns:a="http://schemas.openxmlformats.org/drawingml/2006/main" l="0" t="29622" r="0" b="29622"/>
           <a:stretch xmlns:a="http://schemas.openxmlformats.org/drawingml/2006/main">
             <a:fillRect l="0" t="0" r="0" b="0"/>
@@ -15494,20 +15484,18 @@
         </p:nvSpPr>
         <p:spPr>
           <a:xfrm xmlns:a="http://schemas.openxmlformats.org/drawingml/2006/main">
-            <a:off x="400050" y="1981200"/>
-            <a:ext cx="1428750" cy="19050"/>
+            <a:off x="400050" y="1600200"/>
+            <a:ext cx="2895600" cy="3676650"/>
           </a:xfrm>
           <a:prstGeom xmlns:a="http://schemas.openxmlformats.org/drawingml/2006/main" prst="roundRect">
             <a:avLst>
-              <a:gd name="adj" fmla="val 50000"/>
+              <a:gd name="adj" fmla="val 0"/>
             </a:avLst>
           </a:prstGeom>
-          <a:solidFill xmlns:a="http://schemas.openxmlformats.org/drawingml/2006/main">
-            <a:srgbClr val="75B78E"/>
-          </a:solidFill>
-          <a:ln xmlns:a="http://schemas.openxmlformats.org/drawingml/2006/main" w="0">
+          <a:noFill xmlns:a="http://schemas.openxmlformats.org/drawingml/2006/main"/>
+          <a:ln xmlns:a="http://schemas.openxmlformats.org/drawingml/2006/main" w="7620">
             <a:solidFill>
-              <a:srgbClr val="75B78E"/>
+              <a:srgbClr val="6B5F50"/>
             </a:solidFill>
             <a:prstDash val="solid"/>
           </a:ln>
@@ -15529,8 +15517,8 @@
         </p:nvSpPr>
         <p:spPr>
           <a:xfrm xmlns:a="http://schemas.openxmlformats.org/drawingml/2006/main">
-            <a:off x="400050" y="1676400"/>
-            <a:ext cx="1428750" cy="209550"/>
+            <a:off x="590550" y="1790700"/>
+            <a:ext cx="2381250" cy="209550"/>
           </a:xfrm>
           <a:prstGeom xmlns:a="http://schemas.openxmlformats.org/drawingml/2006/main" prst="rect">
             <a:avLst/>
@@ -15588,21 +15576,21 @@
         </p:nvSpPr>
         <p:spPr>
           <a:xfrm xmlns:a="http://schemas.openxmlformats.org/drawingml/2006/main">
-            <a:off x="400050" y="2228850"/>
-            <a:ext cx="1047750" cy="476250"/>
-          </a:xfrm>
-          <a:prstGeom xmlns:a="http://schemas.openxmlformats.org/drawingml/2006/main" prst="rect">
-            <a:avLst/>
-          </a:prstGeom>
-          <a:noFill xmlns:a="http://schemas.openxmlformats.org/drawingml/2006/main"/>
-          <a:ln xmlns:a="http://schemas.openxmlformats.org/drawingml/2006/main" w="0">
-            <a:noFill/>
-            <a:prstDash val="solid"/>
-          </a:ln>
-        </p:spPr>
-        <p:txBody>
-          <a:bodyPr xmlns:a="http://schemas.openxmlformats.org/drawingml/2006/main" anchor="t">
-            <a:normAutofit fontScale="80159"/>
+            <a:off x="590550" y="2209800"/>
+            <a:ext cx="2381250" cy="438150"/>
+          </a:xfrm>
+          <a:prstGeom xmlns:a="http://schemas.openxmlformats.org/drawingml/2006/main" prst="rect">
+            <a:avLst/>
+          </a:prstGeom>
+          <a:noFill xmlns:a="http://schemas.openxmlformats.org/drawingml/2006/main"/>
+          <a:ln xmlns:a="http://schemas.openxmlformats.org/drawingml/2006/main" w="0">
+            <a:noFill/>
+            <a:prstDash val="solid"/>
+          </a:ln>
+        </p:spPr>
+        <p:txBody>
+          <a:bodyPr xmlns:a="http://schemas.openxmlformats.org/drawingml/2006/main" anchor="t">
+            <a:normAutofit fontScale="79825"/>
           </a:bodyPr>
           <a:lstStyle xmlns:a="http://schemas.openxmlformats.org/drawingml/2006/main"/>
           <a:p xmlns:a="http://schemas.openxmlformats.org/drawingml/2006/main">
@@ -15618,7 +15606,7 @@
               </a:defRPr>
             </a:pPr>
             <a:r>
-              <a:rPr sz="3150" b="0">
+              <a:rPr sz="2850" b="0">
                 <a:solidFill>
                   <a:srgbClr val="F19A68"/>
                 </a:solidFill>
@@ -15647,21 +15635,21 @@
         </p:nvSpPr>
         <p:spPr>
           <a:xfrm xmlns:a="http://schemas.openxmlformats.org/drawingml/2006/main">
-            <a:off x="400050" y="2705100"/>
-            <a:ext cx="1809750" cy="247650"/>
-          </a:xfrm>
-          <a:prstGeom xmlns:a="http://schemas.openxmlformats.org/drawingml/2006/main" prst="rect">
-            <a:avLst/>
-          </a:prstGeom>
-          <a:noFill xmlns:a="http://schemas.openxmlformats.org/drawingml/2006/main"/>
-          <a:ln xmlns:a="http://schemas.openxmlformats.org/drawingml/2006/main" w="0">
-            <a:noFill/>
-            <a:prstDash val="solid"/>
-          </a:ln>
-        </p:spPr>
-        <p:txBody>
-          <a:bodyPr xmlns:a="http://schemas.openxmlformats.org/drawingml/2006/main" anchor="t">
-            <a:normAutofit fontScale="91111"/>
+            <a:off x="590550" y="2647950"/>
+            <a:ext cx="2381250" cy="323850"/>
+          </a:xfrm>
+          <a:prstGeom xmlns:a="http://schemas.openxmlformats.org/drawingml/2006/main" prst="rect">
+            <a:avLst/>
+          </a:prstGeom>
+          <a:noFill xmlns:a="http://schemas.openxmlformats.org/drawingml/2006/main"/>
+          <a:ln xmlns:a="http://schemas.openxmlformats.org/drawingml/2006/main" w="0">
+            <a:noFill/>
+            <a:prstDash val="solid"/>
+          </a:ln>
+        </p:spPr>
+        <p:txBody>
+          <a:bodyPr xmlns:a="http://schemas.openxmlformats.org/drawingml/2006/main" anchor="t">
+            <a:normAutofit fontScale="100000"/>
           </a:bodyPr>
           <a:lstStyle xmlns:a="http://schemas.openxmlformats.org/drawingml/2006/main"/>
           <a:p xmlns:a="http://schemas.openxmlformats.org/drawingml/2006/main">
@@ -15706,21 +15694,21 @@
         </p:nvSpPr>
         <p:spPr>
           <a:xfrm xmlns:a="http://schemas.openxmlformats.org/drawingml/2006/main">
-            <a:off x="400050" y="3257550"/>
-            <a:ext cx="1047750" cy="476250"/>
-          </a:xfrm>
-          <a:prstGeom xmlns:a="http://schemas.openxmlformats.org/drawingml/2006/main" prst="rect">
-            <a:avLst/>
-          </a:prstGeom>
-          <a:noFill xmlns:a="http://schemas.openxmlformats.org/drawingml/2006/main"/>
-          <a:ln xmlns:a="http://schemas.openxmlformats.org/drawingml/2006/main" w="0">
-            <a:noFill/>
-            <a:prstDash val="solid"/>
-          </a:ln>
-        </p:spPr>
-        <p:txBody>
-          <a:bodyPr xmlns:a="http://schemas.openxmlformats.org/drawingml/2006/main" anchor="t">
-            <a:normAutofit fontScale="80159"/>
+            <a:off x="590550" y="3162300"/>
+            <a:ext cx="2381250" cy="438150"/>
+          </a:xfrm>
+          <a:prstGeom xmlns:a="http://schemas.openxmlformats.org/drawingml/2006/main" prst="rect">
+            <a:avLst/>
+          </a:prstGeom>
+          <a:noFill xmlns:a="http://schemas.openxmlformats.org/drawingml/2006/main"/>
+          <a:ln xmlns:a="http://schemas.openxmlformats.org/drawingml/2006/main" w="0">
+            <a:noFill/>
+            <a:prstDash val="solid"/>
+          </a:ln>
+        </p:spPr>
+        <p:txBody>
+          <a:bodyPr xmlns:a="http://schemas.openxmlformats.org/drawingml/2006/main" anchor="t">
+            <a:normAutofit fontScale="79825"/>
           </a:bodyPr>
           <a:lstStyle xmlns:a="http://schemas.openxmlformats.org/drawingml/2006/main"/>
           <a:p xmlns:a="http://schemas.openxmlformats.org/drawingml/2006/main">
@@ -15736,7 +15724,7 @@
               </a:defRPr>
             </a:pPr>
             <a:r>
-              <a:rPr sz="3150" b="0">
+              <a:rPr sz="2850" b="0">
                 <a:solidFill>
                   <a:srgbClr val="F19A68"/>
                 </a:solidFill>
@@ -15765,21 +15753,21 @@
         </p:nvSpPr>
         <p:spPr>
           <a:xfrm xmlns:a="http://schemas.openxmlformats.org/drawingml/2006/main">
-            <a:off x="400050" y="3733800"/>
-            <a:ext cx="1905000" cy="247650"/>
-          </a:xfrm>
-          <a:prstGeom xmlns:a="http://schemas.openxmlformats.org/drawingml/2006/main" prst="rect">
-            <a:avLst/>
-          </a:prstGeom>
-          <a:noFill xmlns:a="http://schemas.openxmlformats.org/drawingml/2006/main"/>
-          <a:ln xmlns:a="http://schemas.openxmlformats.org/drawingml/2006/main" w="0">
-            <a:noFill/>
-            <a:prstDash val="solid"/>
-          </a:ln>
-        </p:spPr>
-        <p:txBody>
-          <a:bodyPr xmlns:a="http://schemas.openxmlformats.org/drawingml/2006/main" anchor="t">
-            <a:normAutofit fontScale="91111"/>
+            <a:off x="590550" y="3600450"/>
+            <a:ext cx="2381250" cy="323850"/>
+          </a:xfrm>
+          <a:prstGeom xmlns:a="http://schemas.openxmlformats.org/drawingml/2006/main" prst="rect">
+            <a:avLst/>
+          </a:prstGeom>
+          <a:noFill xmlns:a="http://schemas.openxmlformats.org/drawingml/2006/main"/>
+          <a:ln xmlns:a="http://schemas.openxmlformats.org/drawingml/2006/main" w="0">
+            <a:noFill/>
+            <a:prstDash val="solid"/>
+          </a:ln>
+        </p:spPr>
+        <p:txBody>
+          <a:bodyPr xmlns:a="http://schemas.openxmlformats.org/drawingml/2006/main" anchor="t">
+            <a:normAutofit fontScale="100000"/>
           </a:bodyPr>
           <a:lstStyle xmlns:a="http://schemas.openxmlformats.org/drawingml/2006/main"/>
           <a:p xmlns:a="http://schemas.openxmlformats.org/drawingml/2006/main">
@@ -15824,21 +15812,21 @@
         </p:nvSpPr>
         <p:spPr>
           <a:xfrm xmlns:a="http://schemas.openxmlformats.org/drawingml/2006/main">
-            <a:off x="400050" y="4305300"/>
-            <a:ext cx="1524000" cy="476250"/>
-          </a:xfrm>
-          <a:prstGeom xmlns:a="http://schemas.openxmlformats.org/drawingml/2006/main" prst="rect">
-            <a:avLst/>
-          </a:prstGeom>
-          <a:noFill xmlns:a="http://schemas.openxmlformats.org/drawingml/2006/main"/>
-          <a:ln xmlns:a="http://schemas.openxmlformats.org/drawingml/2006/main" w="0">
-            <a:noFill/>
-            <a:prstDash val="solid"/>
-          </a:ln>
-        </p:spPr>
-        <p:txBody>
-          <a:bodyPr xmlns:a="http://schemas.openxmlformats.org/drawingml/2006/main" anchor="t">
-            <a:normAutofit fontScale="80159"/>
+            <a:off x="590550" y="4114800"/>
+            <a:ext cx="2381250" cy="438150"/>
+          </a:xfrm>
+          <a:prstGeom xmlns:a="http://schemas.openxmlformats.org/drawingml/2006/main" prst="rect">
+            <a:avLst/>
+          </a:prstGeom>
+          <a:noFill xmlns:a="http://schemas.openxmlformats.org/drawingml/2006/main"/>
+          <a:ln xmlns:a="http://schemas.openxmlformats.org/drawingml/2006/main" w="0">
+            <a:noFill/>
+            <a:prstDash val="solid"/>
+          </a:ln>
+        </p:spPr>
+        <p:txBody>
+          <a:bodyPr xmlns:a="http://schemas.openxmlformats.org/drawingml/2006/main" anchor="t">
+            <a:normAutofit fontScale="79825"/>
           </a:bodyPr>
           <a:lstStyle xmlns:a="http://schemas.openxmlformats.org/drawingml/2006/main"/>
           <a:p xmlns:a="http://schemas.openxmlformats.org/drawingml/2006/main">
@@ -15854,7 +15842,7 @@
               </a:defRPr>
             </a:pPr>
             <a:r>
-              <a:rPr sz="3150" b="0">
+              <a:rPr sz="2850" b="0">
                 <a:solidFill>
                   <a:srgbClr val="F19A68"/>
                 </a:solidFill>
@@ -15883,8 +15871,8 @@
         </p:nvSpPr>
         <p:spPr>
           <a:xfrm xmlns:a="http://schemas.openxmlformats.org/drawingml/2006/main">
-            <a:off x="400050" y="4781550"/>
-            <a:ext cx="2571750" cy="495300"/>
+            <a:off x="590550" y="4552950"/>
+            <a:ext cx="2381250" cy="323850"/>
           </a:xfrm>
           <a:prstGeom xmlns:a="http://schemas.openxmlformats.org/drawingml/2006/main" prst="rect">
             <a:avLst/>
@@ -15942,18 +15930,16 @@
         </p:nvSpPr>
         <p:spPr>
           <a:xfrm xmlns:a="http://schemas.openxmlformats.org/drawingml/2006/main">
-            <a:off x="400050" y="5467350"/>
-            <a:ext cx="2895600" cy="9525"/>
+            <a:off x="400050" y="5429250"/>
+            <a:ext cx="2895600" cy="647700"/>
           </a:xfrm>
           <a:prstGeom xmlns:a="http://schemas.openxmlformats.org/drawingml/2006/main" prst="roundRect">
             <a:avLst>
-              <a:gd name="adj" fmla="val 18750"/>
+              <a:gd name="adj" fmla="val 0"/>
             </a:avLst>
           </a:prstGeom>
-          <a:solidFill xmlns:a="http://schemas.openxmlformats.org/drawingml/2006/main">
-            <a:srgbClr val="6B5F50"/>
-          </a:solidFill>
-          <a:ln xmlns:a="http://schemas.openxmlformats.org/drawingml/2006/main" w="0">
+          <a:noFill xmlns:a="http://schemas.openxmlformats.org/drawingml/2006/main"/>
+          <a:ln xmlns:a="http://schemas.openxmlformats.org/drawingml/2006/main" w="7620">
             <a:solidFill>
               <a:srgbClr val="6B5F50"/>
             </a:solidFill>
@@ -15977,8 +15963,8 @@
         </p:nvSpPr>
         <p:spPr>
           <a:xfrm xmlns:a="http://schemas.openxmlformats.org/drawingml/2006/main">
-            <a:off x="400050" y="5619750"/>
-            <a:ext cx="2895600" cy="266700"/>
+            <a:off x="552450" y="5619750"/>
+            <a:ext cx="2590800" cy="266700"/>
           </a:xfrm>
           <a:prstGeom xmlns:a="http://schemas.openxmlformats.org/drawingml/2006/main" prst="rect">
             <a:avLst/>
@@ -16007,7 +15993,7 @@
               </a:defRPr>
             </a:pPr>
             <a:r>
-              <a:rPr sz="825" b="1">
+              <a:rPr sz="750" b="1">
                 <a:solidFill>
                   <a:srgbClr val="C8BDAE"/>
                 </a:solidFill>
@@ -16301,7 +16287,7 @@
           <p:nvPr/>
         </p:nvPicPr>
         <p:blipFill>
-          <a:blip xmlns:r="http://schemas.openxmlformats.org/officeDocument/2006/relationships" xmlns:a="http://schemas.openxmlformats.org/drawingml/2006/main" r:embed="Re83780bd905f456e"/>
+          <a:blip xmlns:r="http://schemas.openxmlformats.org/officeDocument/2006/relationships" xmlns:a="http://schemas.openxmlformats.org/drawingml/2006/main" r:embed="Rb48bed6b7f7e47b6"/>
           <a:srcRect xmlns:a="http://schemas.openxmlformats.org/drawingml/2006/main" l="0" t="46500" r="0" b="30636"/>
           <a:stretch xmlns:a="http://schemas.openxmlformats.org/drawingml/2006/main">
             <a:fillRect l="0" t="0" r="0" b="0"/>
@@ -17842,19 +17828,17 @@
         <p:spPr>
           <a:xfrm xmlns:a="http://schemas.openxmlformats.org/drawingml/2006/main">
             <a:off x="400050" y="1695450"/>
-            <a:ext cx="2038350" cy="9525"/>
+            <a:ext cx="2038350" cy="2628900"/>
           </a:xfrm>
           <a:prstGeom xmlns:a="http://schemas.openxmlformats.org/drawingml/2006/main" prst="roundRect">
             <a:avLst>
-              <a:gd name="adj" fmla="val 5607"/>
+              <a:gd name="adj" fmla="val 0"/>
             </a:avLst>
           </a:prstGeom>
-          <a:solidFill xmlns:a="http://schemas.openxmlformats.org/drawingml/2006/main">
-            <a:srgbClr val="6B5F50"/>
-          </a:solidFill>
-          <a:ln xmlns:a="http://schemas.openxmlformats.org/drawingml/2006/main" w="0">
+          <a:noFill xmlns:a="http://schemas.openxmlformats.org/drawingml/2006/main"/>
+          <a:ln xmlns:a="http://schemas.openxmlformats.org/drawingml/2006/main" w="11430">
             <a:solidFill>
-              <a:srgbClr val="6B5F50"/>
+              <a:srgbClr val="E8793D"/>
             </a:solidFill>
             <a:prstDash val="solid"/>
           </a:ln>
@@ -18054,19 +18038,17 @@
         <p:spPr>
           <a:xfrm xmlns:a="http://schemas.openxmlformats.org/drawingml/2006/main">
             <a:off x="2667000" y="1962150"/>
-            <a:ext cx="2038350" cy="9525"/>
+            <a:ext cx="2038350" cy="2533650"/>
           </a:xfrm>
           <a:prstGeom xmlns:a="http://schemas.openxmlformats.org/drawingml/2006/main" prst="roundRect">
             <a:avLst>
-              <a:gd name="adj" fmla="val 5607"/>
+              <a:gd name="adj" fmla="val 0"/>
             </a:avLst>
           </a:prstGeom>
-          <a:solidFill xmlns:a="http://schemas.openxmlformats.org/drawingml/2006/main">
-            <a:srgbClr val="6B5F50"/>
-          </a:solidFill>
-          <a:ln xmlns:a="http://schemas.openxmlformats.org/drawingml/2006/main" w="0">
+          <a:noFill xmlns:a="http://schemas.openxmlformats.org/drawingml/2006/main"/>
+          <a:ln xmlns:a="http://schemas.openxmlformats.org/drawingml/2006/main" w="7620">
             <a:solidFill>
-              <a:srgbClr val="6B5F50"/>
+              <a:srgbClr val="3F382E"/>
             </a:solidFill>
             <a:prstDash val="solid"/>
           </a:ln>
@@ -18266,19 +18248,17 @@
         <p:spPr>
           <a:xfrm xmlns:a="http://schemas.openxmlformats.org/drawingml/2006/main">
             <a:off x="4933950" y="2228850"/>
-            <a:ext cx="2038350" cy="9525"/>
+            <a:ext cx="2038350" cy="2438400"/>
           </a:xfrm>
           <a:prstGeom xmlns:a="http://schemas.openxmlformats.org/drawingml/2006/main" prst="roundRect">
             <a:avLst>
-              <a:gd name="adj" fmla="val 5607"/>
+              <a:gd name="adj" fmla="val 0"/>
             </a:avLst>
           </a:prstGeom>
-          <a:solidFill xmlns:a="http://schemas.openxmlformats.org/drawingml/2006/main">
-            <a:srgbClr val="6B5F50"/>
-          </a:solidFill>
-          <a:ln xmlns:a="http://schemas.openxmlformats.org/drawingml/2006/main" w="0">
+          <a:noFill xmlns:a="http://schemas.openxmlformats.org/drawingml/2006/main"/>
+          <a:ln xmlns:a="http://schemas.openxmlformats.org/drawingml/2006/main" w="7620">
             <a:solidFill>
-              <a:srgbClr val="6B5F50"/>
+              <a:srgbClr val="3F382E"/>
             </a:solidFill>
             <a:prstDash val="solid"/>
           </a:ln>
@@ -18478,19 +18458,17 @@
         <p:spPr>
           <a:xfrm xmlns:a="http://schemas.openxmlformats.org/drawingml/2006/main">
             <a:off x="7200900" y="2495550"/>
-            <a:ext cx="2038350" cy="9525"/>
+            <a:ext cx="2038350" cy="2343150"/>
           </a:xfrm>
           <a:prstGeom xmlns:a="http://schemas.openxmlformats.org/drawingml/2006/main" prst="roundRect">
             <a:avLst>
-              <a:gd name="adj" fmla="val 5607"/>
+              <a:gd name="adj" fmla="val 0"/>
             </a:avLst>
           </a:prstGeom>
-          <a:solidFill xmlns:a="http://schemas.openxmlformats.org/drawingml/2006/main">
-            <a:srgbClr val="6B5F50"/>
-          </a:solidFill>
-          <a:ln xmlns:a="http://schemas.openxmlformats.org/drawingml/2006/main" w="0">
+          <a:noFill xmlns:a="http://schemas.openxmlformats.org/drawingml/2006/main"/>
+          <a:ln xmlns:a="http://schemas.openxmlformats.org/drawingml/2006/main" w="7620">
             <a:solidFill>
-              <a:srgbClr val="6B5F50"/>
+              <a:srgbClr val="3F382E"/>
             </a:solidFill>
             <a:prstDash val="solid"/>
           </a:ln>
@@ -18690,17 +18668,15 @@
         <p:spPr>
           <a:xfrm xmlns:a="http://schemas.openxmlformats.org/drawingml/2006/main">
             <a:off x="9467850" y="2762250"/>
-            <a:ext cx="2038350" cy="28575"/>
+            <a:ext cx="2038350" cy="2247900"/>
           </a:xfrm>
           <a:prstGeom xmlns:a="http://schemas.openxmlformats.org/drawingml/2006/main" prst="roundRect">
             <a:avLst>
-              <a:gd name="adj" fmla="val 5607"/>
+              <a:gd name="adj" fmla="val 0"/>
             </a:avLst>
           </a:prstGeom>
-          <a:solidFill xmlns:a="http://schemas.openxmlformats.org/drawingml/2006/main">
-            <a:srgbClr val="75B78E"/>
-          </a:solidFill>
-          <a:ln xmlns:a="http://schemas.openxmlformats.org/drawingml/2006/main" w="0">
+          <a:noFill xmlns:a="http://schemas.openxmlformats.org/drawingml/2006/main"/>
+          <a:ln xmlns:a="http://schemas.openxmlformats.org/drawingml/2006/main" w="11430">
             <a:solidFill>
               <a:srgbClr val="75B78E"/>
             </a:solidFill>

</xml_diff>

<commit_message>
design: align deck imagery and card grids
</commit_message>
<xml_diff>
--- a/docs/submission/APAR_COMPETITION_DECK.pptx
+++ b/docs/submission/APAR_COMPETITION_DECK.pptx
@@ -2,23 +2,23 @@
 <file path=ppt/presentation.xml><?xml version="1.0" encoding="utf-8"?>
 <p:presentation xmlns:p="http://schemas.openxmlformats.org/presentationml/2006/main">
   <p:sldMasterIdLst>
-    <p:sldMasterId xmlns:r="http://schemas.openxmlformats.org/officeDocument/2006/relationships" id="2147483648" r:id="R2cd3fc62273843aa"/>
+    <p:sldMasterId xmlns:r="http://schemas.openxmlformats.org/officeDocument/2006/relationships" id="2147483648" r:id="Rf043c89714ca4998"/>
   </p:sldMasterIdLst>
   <p:notesMasterIdLst>
-    <p:notesMasterId xmlns:r="http://schemas.openxmlformats.org/officeDocument/2006/relationships" r:id="R351acfcfe1dd4b83"/>
+    <p:notesMasterId xmlns:r="http://schemas.openxmlformats.org/officeDocument/2006/relationships" r:id="R50e4f95c92964fde"/>
   </p:notesMasterIdLst>
   <p:sldIdLst>
-    <p:sldId xmlns:r="http://schemas.openxmlformats.org/officeDocument/2006/relationships" id="256" r:id="R2b30af6436884418"/>
-    <p:sldId xmlns:r="http://schemas.openxmlformats.org/officeDocument/2006/relationships" id="257" r:id="R04449302b2814ddb"/>
-    <p:sldId xmlns:r="http://schemas.openxmlformats.org/officeDocument/2006/relationships" id="258" r:id="R5c5fdd481cea4cbb"/>
-    <p:sldId xmlns:r="http://schemas.openxmlformats.org/officeDocument/2006/relationships" id="259" r:id="R7e85c67bfd3f4de6"/>
-    <p:sldId xmlns:r="http://schemas.openxmlformats.org/officeDocument/2006/relationships" id="260" r:id="R285a23eb0a3247cb"/>
-    <p:sldId xmlns:r="http://schemas.openxmlformats.org/officeDocument/2006/relationships" id="261" r:id="R66a2c03cd2064ed9"/>
-    <p:sldId xmlns:r="http://schemas.openxmlformats.org/officeDocument/2006/relationships" id="262" r:id="Rfee801a008154497"/>
-    <p:sldId xmlns:r="http://schemas.openxmlformats.org/officeDocument/2006/relationships" id="263" r:id="R43c3ef3f1ca245e1"/>
-    <p:sldId xmlns:r="http://schemas.openxmlformats.org/officeDocument/2006/relationships" id="264" r:id="R54b352b5718348c4"/>
-    <p:sldId xmlns:r="http://schemas.openxmlformats.org/officeDocument/2006/relationships" id="265" r:id="Re0e413e67d954abc"/>
-    <p:sldId xmlns:r="http://schemas.openxmlformats.org/officeDocument/2006/relationships" id="266" r:id="R18b2effe0dd942f9"/>
+    <p:sldId xmlns:r="http://schemas.openxmlformats.org/officeDocument/2006/relationships" id="256" r:id="R38706f60b2704d13"/>
+    <p:sldId xmlns:r="http://schemas.openxmlformats.org/officeDocument/2006/relationships" id="257" r:id="R4ed8a45f1b89410f"/>
+    <p:sldId xmlns:r="http://schemas.openxmlformats.org/officeDocument/2006/relationships" id="258" r:id="R7df392c0eb8846de"/>
+    <p:sldId xmlns:r="http://schemas.openxmlformats.org/officeDocument/2006/relationships" id="259" r:id="Re24c92aa8c2c4916"/>
+    <p:sldId xmlns:r="http://schemas.openxmlformats.org/officeDocument/2006/relationships" id="260" r:id="R7ebb08f8065f4497"/>
+    <p:sldId xmlns:r="http://schemas.openxmlformats.org/officeDocument/2006/relationships" id="261" r:id="Rdef3fb02294c4973"/>
+    <p:sldId xmlns:r="http://schemas.openxmlformats.org/officeDocument/2006/relationships" id="262" r:id="Rd66d7208b90e419a"/>
+    <p:sldId xmlns:r="http://schemas.openxmlformats.org/officeDocument/2006/relationships" id="263" r:id="R5df4f03cf9b44709"/>
+    <p:sldId xmlns:r="http://schemas.openxmlformats.org/officeDocument/2006/relationships" id="264" r:id="R53215c505acd4917"/>
+    <p:sldId xmlns:r="http://schemas.openxmlformats.org/officeDocument/2006/relationships" id="265" r:id="R190aa44d5c8148ec"/>
+    <p:sldId xmlns:r="http://schemas.openxmlformats.org/officeDocument/2006/relationships" id="266" r:id="R164edc439d5a4d65"/>
   </p:sldIdLst>
   <p:sldSz cx="12192000" cy="6858000"/>
   <p:notesSz cx="6858000" cy="9144000"/>
@@ -1520,7 +1520,7 @@
   </p:cSld>
   <p:clrMap bg1="lt1" tx1="dk1" bg2="lt2" tx2="dk2" accent1="accent1" accent2="accent2" accent3="accent3" accent4="accent4" accent5="accent5" accent6="accent6" hlink="hlink" folHlink="folHlink"/>
   <p:sldLayoutIdLst>
-    <p:sldLayoutId xmlns:r="http://schemas.openxmlformats.org/officeDocument/2006/relationships" id="2147483649" r:id="R4a9adf1f0f19459a"/>
+    <p:sldLayoutId xmlns:r="http://schemas.openxmlformats.org/officeDocument/2006/relationships" id="2147483649" r:id="R65fcc1c9cd9f45aa"/>
   </p:sldLayoutIdLst>
   <p:txStyles>
     <p:titleStyle>
@@ -2462,7 +2462,7 @@
           <p:nvPr/>
         </p:nvPicPr>
         <p:blipFill>
-          <a:blip xmlns:r="http://schemas.openxmlformats.org/officeDocument/2006/relationships" xmlns:a="http://schemas.openxmlformats.org/drawingml/2006/main" r:embed="Rfb0c5d05412a474f"/>
+          <a:blip xmlns:r="http://schemas.openxmlformats.org/officeDocument/2006/relationships" xmlns:a="http://schemas.openxmlformats.org/drawingml/2006/main" r:embed="R698f8ec12c554a1d"/>
           <a:srcRect xmlns:a="http://schemas.openxmlformats.org/drawingml/2006/main" l="0" t="0" r="0" b="32694"/>
           <a:stretch xmlns:a="http://schemas.openxmlformats.org/drawingml/2006/main">
             <a:fillRect l="0" t="0" r="0" b="0"/>
@@ -4400,7 +4400,7 @@
         <p:spPr>
           <a:xfrm xmlns:a="http://schemas.openxmlformats.org/drawingml/2006/main">
             <a:off x="400050" y="1752600"/>
-            <a:ext cx="2019300" cy="2076450"/>
+            <a:ext cx="2076450" cy="2076450"/>
           </a:xfrm>
           <a:prstGeom xmlns:a="http://schemas.openxmlformats.org/drawingml/2006/main" prst="roundRect">
             <a:avLst>
@@ -4492,7 +4492,7 @@
         <p:spPr>
           <a:xfrm xmlns:a="http://schemas.openxmlformats.org/drawingml/2006/main">
             <a:off x="571500" y="2457450"/>
-            <a:ext cx="1676400" cy="457200"/>
+            <a:ext cx="1733550" cy="457200"/>
           </a:xfrm>
           <a:prstGeom xmlns:a="http://schemas.openxmlformats.org/drawingml/2006/main" prst="rect">
             <a:avLst/>
@@ -4551,7 +4551,7 @@
         <p:spPr>
           <a:xfrm xmlns:a="http://schemas.openxmlformats.org/drawingml/2006/main">
             <a:off x="571500" y="3105150"/>
-            <a:ext cx="1676400" cy="552450"/>
+            <a:ext cx="1733550" cy="552450"/>
           </a:xfrm>
           <a:prstGeom xmlns:a="http://schemas.openxmlformats.org/drawingml/2006/main" prst="rect">
             <a:avLst/>
@@ -4609,21 +4609,21 @@
         </p:nvSpPr>
         <p:spPr>
           <a:xfrm xmlns:a="http://schemas.openxmlformats.org/drawingml/2006/main">
-            <a:off x="2400300" y="2686050"/>
-            <a:ext cx="266700" cy="304800"/>
-          </a:xfrm>
-          <a:prstGeom xmlns:a="http://schemas.openxmlformats.org/drawingml/2006/main" prst="rect">
-            <a:avLst/>
-          </a:prstGeom>
-          <a:noFill xmlns:a="http://schemas.openxmlformats.org/drawingml/2006/main"/>
-          <a:ln xmlns:a="http://schemas.openxmlformats.org/drawingml/2006/main" w="0">
-            <a:noFill/>
-            <a:prstDash val="solid"/>
-          </a:ln>
-        </p:spPr>
-        <p:txBody>
-          <a:bodyPr xmlns:a="http://schemas.openxmlformats.org/drawingml/2006/main" anchor="t">
-            <a:normAutofit fontScale="39748"/>
+            <a:off x="2476500" y="2686050"/>
+            <a:ext cx="252413" cy="304800"/>
+          </a:xfrm>
+          <a:prstGeom xmlns:a="http://schemas.openxmlformats.org/drawingml/2006/main" prst="rect">
+            <a:avLst/>
+          </a:prstGeom>
+          <a:noFill xmlns:a="http://schemas.openxmlformats.org/drawingml/2006/main"/>
+          <a:ln xmlns:a="http://schemas.openxmlformats.org/drawingml/2006/main" w="0">
+            <a:noFill/>
+            <a:prstDash val="solid"/>
+          </a:ln>
+        </p:spPr>
+        <p:txBody>
+          <a:bodyPr xmlns:a="http://schemas.openxmlformats.org/drawingml/2006/main" anchor="t">
+            <a:normAutofit fontScale="32929"/>
           </a:bodyPr>
           <a:lstStyle xmlns:a="http://schemas.openxmlformats.org/drawingml/2006/main"/>
           <a:p xmlns:a="http://schemas.openxmlformats.org/drawingml/2006/main">
@@ -4668,8 +4668,8 @@
         </p:nvSpPr>
         <p:spPr>
           <a:xfrm xmlns:a="http://schemas.openxmlformats.org/drawingml/2006/main">
-            <a:off x="2667000" y="1752600"/>
-            <a:ext cx="2019300" cy="2076450"/>
+            <a:off x="2728913" y="1752600"/>
+            <a:ext cx="2076450" cy="2076450"/>
           </a:xfrm>
           <a:prstGeom xmlns:a="http://schemas.openxmlformats.org/drawingml/2006/main" prst="roundRect">
             <a:avLst>
@@ -4701,7 +4701,7 @@
         </p:nvSpPr>
         <p:spPr>
           <a:xfrm xmlns:a="http://schemas.openxmlformats.org/drawingml/2006/main">
-            <a:off x="2838450" y="1943100"/>
+            <a:off x="2900363" y="1943100"/>
             <a:ext cx="304800" cy="266700"/>
           </a:xfrm>
           <a:prstGeom xmlns:a="http://schemas.openxmlformats.org/drawingml/2006/main" prst="rect">
@@ -4760,8 +4760,8 @@
         </p:nvSpPr>
         <p:spPr>
           <a:xfrm xmlns:a="http://schemas.openxmlformats.org/drawingml/2006/main">
-            <a:off x="2838450" y="2457450"/>
-            <a:ext cx="1676400" cy="457200"/>
+            <a:off x="2900363" y="2457450"/>
+            <a:ext cx="1733550" cy="457200"/>
           </a:xfrm>
           <a:prstGeom xmlns:a="http://schemas.openxmlformats.org/drawingml/2006/main" prst="rect">
             <a:avLst/>
@@ -4819,8 +4819,8 @@
         </p:nvSpPr>
         <p:spPr>
           <a:xfrm xmlns:a="http://schemas.openxmlformats.org/drawingml/2006/main">
-            <a:off x="2838450" y="3105150"/>
-            <a:ext cx="1676400" cy="552450"/>
+            <a:off x="2900363" y="3105150"/>
+            <a:ext cx="1733550" cy="552450"/>
           </a:xfrm>
           <a:prstGeom xmlns:a="http://schemas.openxmlformats.org/drawingml/2006/main" prst="rect">
             <a:avLst/>
@@ -4878,21 +4878,21 @@
         </p:nvSpPr>
         <p:spPr>
           <a:xfrm xmlns:a="http://schemas.openxmlformats.org/drawingml/2006/main">
-            <a:off x="4667250" y="2686050"/>
-            <a:ext cx="266700" cy="304800"/>
-          </a:xfrm>
-          <a:prstGeom xmlns:a="http://schemas.openxmlformats.org/drawingml/2006/main" prst="rect">
-            <a:avLst/>
-          </a:prstGeom>
-          <a:noFill xmlns:a="http://schemas.openxmlformats.org/drawingml/2006/main"/>
-          <a:ln xmlns:a="http://schemas.openxmlformats.org/drawingml/2006/main" w="0">
-            <a:noFill/>
-            <a:prstDash val="solid"/>
-          </a:ln>
-        </p:spPr>
-        <p:txBody>
-          <a:bodyPr xmlns:a="http://schemas.openxmlformats.org/drawingml/2006/main" anchor="t">
-            <a:normAutofit fontScale="39748"/>
+            <a:off x="4805363" y="2686050"/>
+            <a:ext cx="252413" cy="304800"/>
+          </a:xfrm>
+          <a:prstGeom xmlns:a="http://schemas.openxmlformats.org/drawingml/2006/main" prst="rect">
+            <a:avLst/>
+          </a:prstGeom>
+          <a:noFill xmlns:a="http://schemas.openxmlformats.org/drawingml/2006/main"/>
+          <a:ln xmlns:a="http://schemas.openxmlformats.org/drawingml/2006/main" w="0">
+            <a:noFill/>
+            <a:prstDash val="solid"/>
+          </a:ln>
+        </p:spPr>
+        <p:txBody>
+          <a:bodyPr xmlns:a="http://schemas.openxmlformats.org/drawingml/2006/main" anchor="t">
+            <a:normAutofit fontScale="32929"/>
           </a:bodyPr>
           <a:lstStyle xmlns:a="http://schemas.openxmlformats.org/drawingml/2006/main"/>
           <a:p xmlns:a="http://schemas.openxmlformats.org/drawingml/2006/main">
@@ -4937,8 +4937,8 @@
         </p:nvSpPr>
         <p:spPr>
           <a:xfrm xmlns:a="http://schemas.openxmlformats.org/drawingml/2006/main">
-            <a:off x="4933950" y="1752600"/>
-            <a:ext cx="2019300" cy="2076450"/>
+            <a:off x="5057775" y="1752600"/>
+            <a:ext cx="2076450" cy="2076450"/>
           </a:xfrm>
           <a:prstGeom xmlns:a="http://schemas.openxmlformats.org/drawingml/2006/main" prst="roundRect">
             <a:avLst>
@@ -4970,7 +4970,7 @@
         </p:nvSpPr>
         <p:spPr>
           <a:xfrm xmlns:a="http://schemas.openxmlformats.org/drawingml/2006/main">
-            <a:off x="5105400" y="1943100"/>
+            <a:off x="5229225" y="1943100"/>
             <a:ext cx="304800" cy="266700"/>
           </a:xfrm>
           <a:prstGeom xmlns:a="http://schemas.openxmlformats.org/drawingml/2006/main" prst="rect">
@@ -5029,8 +5029,8 @@
         </p:nvSpPr>
         <p:spPr>
           <a:xfrm xmlns:a="http://schemas.openxmlformats.org/drawingml/2006/main">
-            <a:off x="5105400" y="2457450"/>
-            <a:ext cx="1676400" cy="457200"/>
+            <a:off x="5229225" y="2457450"/>
+            <a:ext cx="1733550" cy="457200"/>
           </a:xfrm>
           <a:prstGeom xmlns:a="http://schemas.openxmlformats.org/drawingml/2006/main" prst="rect">
             <a:avLst/>
@@ -5088,8 +5088,8 @@
         </p:nvSpPr>
         <p:spPr>
           <a:xfrm xmlns:a="http://schemas.openxmlformats.org/drawingml/2006/main">
-            <a:off x="5105400" y="3105150"/>
-            <a:ext cx="1676400" cy="552450"/>
+            <a:off x="5229225" y="3105150"/>
+            <a:ext cx="1733550" cy="552450"/>
           </a:xfrm>
           <a:prstGeom xmlns:a="http://schemas.openxmlformats.org/drawingml/2006/main" prst="rect">
             <a:avLst/>
@@ -5147,21 +5147,21 @@
         </p:nvSpPr>
         <p:spPr>
           <a:xfrm xmlns:a="http://schemas.openxmlformats.org/drawingml/2006/main">
-            <a:off x="6934200" y="2686050"/>
-            <a:ext cx="266700" cy="304800"/>
-          </a:xfrm>
-          <a:prstGeom xmlns:a="http://schemas.openxmlformats.org/drawingml/2006/main" prst="rect">
-            <a:avLst/>
-          </a:prstGeom>
-          <a:noFill xmlns:a="http://schemas.openxmlformats.org/drawingml/2006/main"/>
-          <a:ln xmlns:a="http://schemas.openxmlformats.org/drawingml/2006/main" w="0">
-            <a:noFill/>
-            <a:prstDash val="solid"/>
-          </a:ln>
-        </p:spPr>
-        <p:txBody>
-          <a:bodyPr xmlns:a="http://schemas.openxmlformats.org/drawingml/2006/main" anchor="t">
-            <a:normAutofit fontScale="39748"/>
+            <a:off x="7134225" y="2686050"/>
+            <a:ext cx="252413" cy="304800"/>
+          </a:xfrm>
+          <a:prstGeom xmlns:a="http://schemas.openxmlformats.org/drawingml/2006/main" prst="rect">
+            <a:avLst/>
+          </a:prstGeom>
+          <a:noFill xmlns:a="http://schemas.openxmlformats.org/drawingml/2006/main"/>
+          <a:ln xmlns:a="http://schemas.openxmlformats.org/drawingml/2006/main" w="0">
+            <a:noFill/>
+            <a:prstDash val="solid"/>
+          </a:ln>
+        </p:spPr>
+        <p:txBody>
+          <a:bodyPr xmlns:a="http://schemas.openxmlformats.org/drawingml/2006/main" anchor="t">
+            <a:normAutofit fontScale="32929"/>
           </a:bodyPr>
           <a:lstStyle xmlns:a="http://schemas.openxmlformats.org/drawingml/2006/main"/>
           <a:p xmlns:a="http://schemas.openxmlformats.org/drawingml/2006/main">
@@ -5206,8 +5206,8 @@
         </p:nvSpPr>
         <p:spPr>
           <a:xfrm xmlns:a="http://schemas.openxmlformats.org/drawingml/2006/main">
-            <a:off x="7200900" y="1752600"/>
-            <a:ext cx="2019300" cy="2076450"/>
+            <a:off x="7386638" y="1752600"/>
+            <a:ext cx="2076450" cy="2076450"/>
           </a:xfrm>
           <a:prstGeom xmlns:a="http://schemas.openxmlformats.org/drawingml/2006/main" prst="roundRect">
             <a:avLst>
@@ -5239,7 +5239,7 @@
         </p:nvSpPr>
         <p:spPr>
           <a:xfrm xmlns:a="http://schemas.openxmlformats.org/drawingml/2006/main">
-            <a:off x="7372350" y="1943100"/>
+            <a:off x="7558088" y="1943100"/>
             <a:ext cx="304800" cy="266700"/>
           </a:xfrm>
           <a:prstGeom xmlns:a="http://schemas.openxmlformats.org/drawingml/2006/main" prst="rect">
@@ -5298,8 +5298,8 @@
         </p:nvSpPr>
         <p:spPr>
           <a:xfrm xmlns:a="http://schemas.openxmlformats.org/drawingml/2006/main">
-            <a:off x="7372350" y="2457450"/>
-            <a:ext cx="1676400" cy="457200"/>
+            <a:off x="7558088" y="2457450"/>
+            <a:ext cx="1733550" cy="457200"/>
           </a:xfrm>
           <a:prstGeom xmlns:a="http://schemas.openxmlformats.org/drawingml/2006/main" prst="rect">
             <a:avLst/>
@@ -5357,8 +5357,8 @@
         </p:nvSpPr>
         <p:spPr>
           <a:xfrm xmlns:a="http://schemas.openxmlformats.org/drawingml/2006/main">
-            <a:off x="7372350" y="3105150"/>
-            <a:ext cx="1676400" cy="552450"/>
+            <a:off x="7558088" y="3105150"/>
+            <a:ext cx="1733550" cy="552450"/>
           </a:xfrm>
           <a:prstGeom xmlns:a="http://schemas.openxmlformats.org/drawingml/2006/main" prst="rect">
             <a:avLst/>
@@ -5416,21 +5416,21 @@
         </p:nvSpPr>
         <p:spPr>
           <a:xfrm xmlns:a="http://schemas.openxmlformats.org/drawingml/2006/main">
-            <a:off x="9201150" y="2686050"/>
-            <a:ext cx="266700" cy="304800"/>
-          </a:xfrm>
-          <a:prstGeom xmlns:a="http://schemas.openxmlformats.org/drawingml/2006/main" prst="rect">
-            <a:avLst/>
-          </a:prstGeom>
-          <a:noFill xmlns:a="http://schemas.openxmlformats.org/drawingml/2006/main"/>
-          <a:ln xmlns:a="http://schemas.openxmlformats.org/drawingml/2006/main" w="0">
-            <a:noFill/>
-            <a:prstDash val="solid"/>
-          </a:ln>
-        </p:spPr>
-        <p:txBody>
-          <a:bodyPr xmlns:a="http://schemas.openxmlformats.org/drawingml/2006/main" anchor="t">
-            <a:normAutofit fontScale="39748"/>
+            <a:off x="9463088" y="2686050"/>
+            <a:ext cx="252413" cy="304800"/>
+          </a:xfrm>
+          <a:prstGeom xmlns:a="http://schemas.openxmlformats.org/drawingml/2006/main" prst="rect">
+            <a:avLst/>
+          </a:prstGeom>
+          <a:noFill xmlns:a="http://schemas.openxmlformats.org/drawingml/2006/main"/>
+          <a:ln xmlns:a="http://schemas.openxmlformats.org/drawingml/2006/main" w="0">
+            <a:noFill/>
+            <a:prstDash val="solid"/>
+          </a:ln>
+        </p:spPr>
+        <p:txBody>
+          <a:bodyPr xmlns:a="http://schemas.openxmlformats.org/drawingml/2006/main" anchor="t">
+            <a:normAutofit fontScale="32929"/>
           </a:bodyPr>
           <a:lstStyle xmlns:a="http://schemas.openxmlformats.org/drawingml/2006/main"/>
           <a:p xmlns:a="http://schemas.openxmlformats.org/drawingml/2006/main">
@@ -5475,8 +5475,8 @@
         </p:nvSpPr>
         <p:spPr>
           <a:xfrm xmlns:a="http://schemas.openxmlformats.org/drawingml/2006/main">
-            <a:off x="9467850" y="1752600"/>
-            <a:ext cx="2019300" cy="2076450"/>
+            <a:off x="9715500" y="1752600"/>
+            <a:ext cx="2076450" cy="2076450"/>
           </a:xfrm>
           <a:prstGeom xmlns:a="http://schemas.openxmlformats.org/drawingml/2006/main" prst="roundRect">
             <a:avLst>
@@ -5508,7 +5508,7 @@
         </p:nvSpPr>
         <p:spPr>
           <a:xfrm xmlns:a="http://schemas.openxmlformats.org/drawingml/2006/main">
-            <a:off x="9639300" y="1943100"/>
+            <a:off x="9886950" y="1943100"/>
             <a:ext cx="304800" cy="266700"/>
           </a:xfrm>
           <a:prstGeom xmlns:a="http://schemas.openxmlformats.org/drawingml/2006/main" prst="rect">
@@ -5567,8 +5567,8 @@
         </p:nvSpPr>
         <p:spPr>
           <a:xfrm xmlns:a="http://schemas.openxmlformats.org/drawingml/2006/main">
-            <a:off x="9639300" y="2457450"/>
-            <a:ext cx="1676400" cy="457200"/>
+            <a:off x="9886950" y="2457450"/>
+            <a:ext cx="1733550" cy="457200"/>
           </a:xfrm>
           <a:prstGeom xmlns:a="http://schemas.openxmlformats.org/drawingml/2006/main" prst="rect">
             <a:avLst/>
@@ -5626,8 +5626,8 @@
         </p:nvSpPr>
         <p:spPr>
           <a:xfrm xmlns:a="http://schemas.openxmlformats.org/drawingml/2006/main">
-            <a:off x="9639300" y="3105150"/>
-            <a:ext cx="1676400" cy="552450"/>
+            <a:off x="9886950" y="3105150"/>
+            <a:ext cx="1733550" cy="552450"/>
           </a:xfrm>
           <a:prstGeom xmlns:a="http://schemas.openxmlformats.org/drawingml/2006/main" prst="rect">
             <a:avLst/>
@@ -11328,7 +11328,7 @@
         <p:spPr>
           <a:xfrm xmlns:a="http://schemas.openxmlformats.org/drawingml/2006/main">
             <a:off x="3257550" y="1905000"/>
-            <a:ext cx="1428750" cy="457200"/>
+            <a:ext cx="1619250" cy="457200"/>
           </a:xfrm>
           <a:prstGeom xmlns:a="http://schemas.openxmlformats.org/drawingml/2006/main" prst="roundRect">
             <a:avLst>
@@ -11361,7 +11361,7 @@
         <p:spPr>
           <a:xfrm xmlns:a="http://schemas.openxmlformats.org/drawingml/2006/main">
             <a:off x="3352800" y="2038350"/>
-            <a:ext cx="1238250" cy="190500"/>
+            <a:ext cx="1428750" cy="190500"/>
           </a:xfrm>
           <a:prstGeom xmlns:a="http://schemas.openxmlformats.org/drawingml/2006/main" prst="rect">
             <a:avLst/>
@@ -11419,8 +11419,8 @@
         </p:nvSpPr>
         <p:spPr>
           <a:xfrm xmlns:a="http://schemas.openxmlformats.org/drawingml/2006/main">
-            <a:off x="4686300" y="1905000"/>
-            <a:ext cx="1428750" cy="457200"/>
+            <a:off x="4876800" y="1905000"/>
+            <a:ext cx="1619250" cy="457200"/>
           </a:xfrm>
           <a:prstGeom xmlns:a="http://schemas.openxmlformats.org/drawingml/2006/main" prst="roundRect">
             <a:avLst>
@@ -11452,8 +11452,8 @@
         </p:nvSpPr>
         <p:spPr>
           <a:xfrm xmlns:a="http://schemas.openxmlformats.org/drawingml/2006/main">
-            <a:off x="4781550" y="2038350"/>
-            <a:ext cx="1238250" cy="190500"/>
+            <a:off x="4972050" y="2038350"/>
+            <a:ext cx="1428750" cy="190500"/>
           </a:xfrm>
           <a:prstGeom xmlns:a="http://schemas.openxmlformats.org/drawingml/2006/main" prst="rect">
             <a:avLst/>
@@ -11511,8 +11511,8 @@
         </p:nvSpPr>
         <p:spPr>
           <a:xfrm xmlns:a="http://schemas.openxmlformats.org/drawingml/2006/main">
-            <a:off x="6115050" y="1905000"/>
-            <a:ext cx="1428750" cy="457200"/>
+            <a:off x="6496050" y="1905000"/>
+            <a:ext cx="1619250" cy="457200"/>
           </a:xfrm>
           <a:prstGeom xmlns:a="http://schemas.openxmlformats.org/drawingml/2006/main" prst="roundRect">
             <a:avLst>
@@ -11544,8 +11544,8 @@
         </p:nvSpPr>
         <p:spPr>
           <a:xfrm xmlns:a="http://schemas.openxmlformats.org/drawingml/2006/main">
-            <a:off x="6210300" y="2038350"/>
-            <a:ext cx="1238250" cy="190500"/>
+            <a:off x="6591300" y="2038350"/>
+            <a:ext cx="1428750" cy="190500"/>
           </a:xfrm>
           <a:prstGeom xmlns:a="http://schemas.openxmlformats.org/drawingml/2006/main" prst="rect">
             <a:avLst/>
@@ -11603,8 +11603,8 @@
         </p:nvSpPr>
         <p:spPr>
           <a:xfrm xmlns:a="http://schemas.openxmlformats.org/drawingml/2006/main">
-            <a:off x="7543800" y="1905000"/>
-            <a:ext cx="1809750" cy="457200"/>
+            <a:off x="8115300" y="1905000"/>
+            <a:ext cx="2057400" cy="457200"/>
           </a:xfrm>
           <a:prstGeom xmlns:a="http://schemas.openxmlformats.org/drawingml/2006/main" prst="roundRect">
             <a:avLst>
@@ -11636,8 +11636,8 @@
         </p:nvSpPr>
         <p:spPr>
           <a:xfrm xmlns:a="http://schemas.openxmlformats.org/drawingml/2006/main">
-            <a:off x="7639050" y="2038350"/>
-            <a:ext cx="1619250" cy="190500"/>
+            <a:off x="8210550" y="2038350"/>
+            <a:ext cx="1866900" cy="190500"/>
           </a:xfrm>
           <a:prstGeom xmlns:a="http://schemas.openxmlformats.org/drawingml/2006/main" prst="rect">
             <a:avLst/>
@@ -11695,8 +11695,8 @@
         </p:nvSpPr>
         <p:spPr>
           <a:xfrm xmlns:a="http://schemas.openxmlformats.org/drawingml/2006/main">
-            <a:off x="9353550" y="1905000"/>
-            <a:ext cx="1428750" cy="457200"/>
+            <a:off x="10172700" y="1905000"/>
+            <a:ext cx="1619250" cy="457200"/>
           </a:xfrm>
           <a:prstGeom xmlns:a="http://schemas.openxmlformats.org/drawingml/2006/main" prst="roundRect">
             <a:avLst>
@@ -11728,8 +11728,8 @@
         </p:nvSpPr>
         <p:spPr>
           <a:xfrm xmlns:a="http://schemas.openxmlformats.org/drawingml/2006/main">
-            <a:off x="9448800" y="2038350"/>
-            <a:ext cx="1238250" cy="190500"/>
+            <a:off x="10267950" y="2038350"/>
+            <a:ext cx="1428750" cy="190500"/>
           </a:xfrm>
           <a:prstGeom xmlns:a="http://schemas.openxmlformats.org/drawingml/2006/main" prst="rect">
             <a:avLst/>
@@ -11880,7 +11880,7 @@
         <p:spPr>
           <a:xfrm xmlns:a="http://schemas.openxmlformats.org/drawingml/2006/main">
             <a:off x="3257550" y="2362200"/>
-            <a:ext cx="1428750" cy="628650"/>
+            <a:ext cx="1619250" cy="628650"/>
           </a:xfrm>
           <a:prstGeom xmlns:a="http://schemas.openxmlformats.org/drawingml/2006/main" prst="roundRect">
             <a:avLst>
@@ -11913,7 +11913,7 @@
         <p:spPr>
           <a:xfrm xmlns:a="http://schemas.openxmlformats.org/drawingml/2006/main">
             <a:off x="3352800" y="2562225"/>
-            <a:ext cx="1238250" cy="238125"/>
+            <a:ext cx="1428750" cy="238125"/>
           </a:xfrm>
           <a:prstGeom xmlns:a="http://schemas.openxmlformats.org/drawingml/2006/main" prst="rect">
             <a:avLst/>
@@ -11971,8 +11971,8 @@
         </p:nvSpPr>
         <p:spPr>
           <a:xfrm xmlns:a="http://schemas.openxmlformats.org/drawingml/2006/main">
-            <a:off x="4686300" y="2362200"/>
-            <a:ext cx="1428750" cy="628650"/>
+            <a:off x="4876800" y="2362200"/>
+            <a:ext cx="1619250" cy="628650"/>
           </a:xfrm>
           <a:prstGeom xmlns:a="http://schemas.openxmlformats.org/drawingml/2006/main" prst="roundRect">
             <a:avLst>
@@ -12004,8 +12004,8 @@
         </p:nvSpPr>
         <p:spPr>
           <a:xfrm xmlns:a="http://schemas.openxmlformats.org/drawingml/2006/main">
-            <a:off x="4781550" y="2562225"/>
-            <a:ext cx="1238250" cy="238125"/>
+            <a:off x="4972050" y="2562225"/>
+            <a:ext cx="1428750" cy="238125"/>
           </a:xfrm>
           <a:prstGeom xmlns:a="http://schemas.openxmlformats.org/drawingml/2006/main" prst="rect">
             <a:avLst/>
@@ -12063,8 +12063,8 @@
         </p:nvSpPr>
         <p:spPr>
           <a:xfrm xmlns:a="http://schemas.openxmlformats.org/drawingml/2006/main">
-            <a:off x="6115050" y="2362200"/>
-            <a:ext cx="1428750" cy="628650"/>
+            <a:off x="6496050" y="2362200"/>
+            <a:ext cx="1619250" cy="628650"/>
           </a:xfrm>
           <a:prstGeom xmlns:a="http://schemas.openxmlformats.org/drawingml/2006/main" prst="roundRect">
             <a:avLst>
@@ -12096,8 +12096,8 @@
         </p:nvSpPr>
         <p:spPr>
           <a:xfrm xmlns:a="http://schemas.openxmlformats.org/drawingml/2006/main">
-            <a:off x="6210300" y="2562225"/>
-            <a:ext cx="1238250" cy="238125"/>
+            <a:off x="6591300" y="2562225"/>
+            <a:ext cx="1428750" cy="238125"/>
           </a:xfrm>
           <a:prstGeom xmlns:a="http://schemas.openxmlformats.org/drawingml/2006/main" prst="rect">
             <a:avLst/>
@@ -12155,8 +12155,8 @@
         </p:nvSpPr>
         <p:spPr>
           <a:xfrm xmlns:a="http://schemas.openxmlformats.org/drawingml/2006/main">
-            <a:off x="7543800" y="2362200"/>
-            <a:ext cx="1809750" cy="628650"/>
+            <a:off x="8115300" y="2362200"/>
+            <a:ext cx="2057400" cy="628650"/>
           </a:xfrm>
           <a:prstGeom xmlns:a="http://schemas.openxmlformats.org/drawingml/2006/main" prst="roundRect">
             <a:avLst>
@@ -12188,8 +12188,8 @@
         </p:nvSpPr>
         <p:spPr>
           <a:xfrm xmlns:a="http://schemas.openxmlformats.org/drawingml/2006/main">
-            <a:off x="7639050" y="2562225"/>
-            <a:ext cx="1619250" cy="238125"/>
+            <a:off x="8210550" y="2562225"/>
+            <a:ext cx="1866900" cy="238125"/>
           </a:xfrm>
           <a:prstGeom xmlns:a="http://schemas.openxmlformats.org/drawingml/2006/main" prst="rect">
             <a:avLst/>
@@ -12247,8 +12247,8 @@
         </p:nvSpPr>
         <p:spPr>
           <a:xfrm xmlns:a="http://schemas.openxmlformats.org/drawingml/2006/main">
-            <a:off x="9353550" y="2362200"/>
-            <a:ext cx="1428750" cy="628650"/>
+            <a:off x="10172700" y="2362200"/>
+            <a:ext cx="1619250" cy="628650"/>
           </a:xfrm>
           <a:prstGeom xmlns:a="http://schemas.openxmlformats.org/drawingml/2006/main" prst="roundRect">
             <a:avLst>
@@ -12280,8 +12280,8 @@
         </p:nvSpPr>
         <p:spPr>
           <a:xfrm xmlns:a="http://schemas.openxmlformats.org/drawingml/2006/main">
-            <a:off x="9448800" y="2562225"/>
-            <a:ext cx="1238250" cy="238125"/>
+            <a:off x="10267950" y="2562225"/>
+            <a:ext cx="1428750" cy="238125"/>
           </a:xfrm>
           <a:prstGeom xmlns:a="http://schemas.openxmlformats.org/drawingml/2006/main" prst="rect">
             <a:avLst/>
@@ -12432,7 +12432,7 @@
         <p:spPr>
           <a:xfrm xmlns:a="http://schemas.openxmlformats.org/drawingml/2006/main">
             <a:off x="3257550" y="2990850"/>
-            <a:ext cx="1428750" cy="628650"/>
+            <a:ext cx="1619250" cy="628650"/>
           </a:xfrm>
           <a:prstGeom xmlns:a="http://schemas.openxmlformats.org/drawingml/2006/main" prst="roundRect">
             <a:avLst>
@@ -12465,7 +12465,7 @@
         <p:spPr>
           <a:xfrm xmlns:a="http://schemas.openxmlformats.org/drawingml/2006/main">
             <a:off x="3352800" y="3190875"/>
-            <a:ext cx="1238250" cy="238125"/>
+            <a:ext cx="1428750" cy="238125"/>
           </a:xfrm>
           <a:prstGeom xmlns:a="http://schemas.openxmlformats.org/drawingml/2006/main" prst="rect">
             <a:avLst/>
@@ -12523,8 +12523,8 @@
         </p:nvSpPr>
         <p:spPr>
           <a:xfrm xmlns:a="http://schemas.openxmlformats.org/drawingml/2006/main">
-            <a:off x="4686300" y="2990850"/>
-            <a:ext cx="1428750" cy="628650"/>
+            <a:off x="4876800" y="2990850"/>
+            <a:ext cx="1619250" cy="628650"/>
           </a:xfrm>
           <a:prstGeom xmlns:a="http://schemas.openxmlformats.org/drawingml/2006/main" prst="roundRect">
             <a:avLst>
@@ -12556,8 +12556,8 @@
         </p:nvSpPr>
         <p:spPr>
           <a:xfrm xmlns:a="http://schemas.openxmlformats.org/drawingml/2006/main">
-            <a:off x="4781550" y="3190875"/>
-            <a:ext cx="1238250" cy="238125"/>
+            <a:off x="4972050" y="3190875"/>
+            <a:ext cx="1428750" cy="238125"/>
           </a:xfrm>
           <a:prstGeom xmlns:a="http://schemas.openxmlformats.org/drawingml/2006/main" prst="rect">
             <a:avLst/>
@@ -12615,8 +12615,8 @@
         </p:nvSpPr>
         <p:spPr>
           <a:xfrm xmlns:a="http://schemas.openxmlformats.org/drawingml/2006/main">
-            <a:off x="6115050" y="2990850"/>
-            <a:ext cx="1428750" cy="628650"/>
+            <a:off x="6496050" y="2990850"/>
+            <a:ext cx="1619250" cy="628650"/>
           </a:xfrm>
           <a:prstGeom xmlns:a="http://schemas.openxmlformats.org/drawingml/2006/main" prst="roundRect">
             <a:avLst>
@@ -12648,8 +12648,8 @@
         </p:nvSpPr>
         <p:spPr>
           <a:xfrm xmlns:a="http://schemas.openxmlformats.org/drawingml/2006/main">
-            <a:off x="6210300" y="3190875"/>
-            <a:ext cx="1238250" cy="238125"/>
+            <a:off x="6591300" y="3190875"/>
+            <a:ext cx="1428750" cy="238125"/>
           </a:xfrm>
           <a:prstGeom xmlns:a="http://schemas.openxmlformats.org/drawingml/2006/main" prst="rect">
             <a:avLst/>
@@ -12707,8 +12707,8 @@
         </p:nvSpPr>
         <p:spPr>
           <a:xfrm xmlns:a="http://schemas.openxmlformats.org/drawingml/2006/main">
-            <a:off x="7543800" y="2990850"/>
-            <a:ext cx="1809750" cy="628650"/>
+            <a:off x="8115300" y="2990850"/>
+            <a:ext cx="2057400" cy="628650"/>
           </a:xfrm>
           <a:prstGeom xmlns:a="http://schemas.openxmlformats.org/drawingml/2006/main" prst="roundRect">
             <a:avLst>
@@ -12740,8 +12740,8 @@
         </p:nvSpPr>
         <p:spPr>
           <a:xfrm xmlns:a="http://schemas.openxmlformats.org/drawingml/2006/main">
-            <a:off x="7639050" y="3190875"/>
-            <a:ext cx="1619250" cy="238125"/>
+            <a:off x="8210550" y="3190875"/>
+            <a:ext cx="1866900" cy="238125"/>
           </a:xfrm>
           <a:prstGeom xmlns:a="http://schemas.openxmlformats.org/drawingml/2006/main" prst="rect">
             <a:avLst/>
@@ -12799,8 +12799,8 @@
         </p:nvSpPr>
         <p:spPr>
           <a:xfrm xmlns:a="http://schemas.openxmlformats.org/drawingml/2006/main">
-            <a:off x="9353550" y="2990850"/>
-            <a:ext cx="1428750" cy="628650"/>
+            <a:off x="10172700" y="2990850"/>
+            <a:ext cx="1619250" cy="628650"/>
           </a:xfrm>
           <a:prstGeom xmlns:a="http://schemas.openxmlformats.org/drawingml/2006/main" prst="roundRect">
             <a:avLst>
@@ -12832,8 +12832,8 @@
         </p:nvSpPr>
         <p:spPr>
           <a:xfrm xmlns:a="http://schemas.openxmlformats.org/drawingml/2006/main">
-            <a:off x="9448800" y="3190875"/>
-            <a:ext cx="1238250" cy="238125"/>
+            <a:off x="10267950" y="3190875"/>
+            <a:ext cx="1428750" cy="238125"/>
           </a:xfrm>
           <a:prstGeom xmlns:a="http://schemas.openxmlformats.org/drawingml/2006/main" prst="rect">
             <a:avLst/>
@@ -12986,7 +12986,7 @@
         <p:spPr>
           <a:xfrm xmlns:a="http://schemas.openxmlformats.org/drawingml/2006/main">
             <a:off x="3257550" y="3619500"/>
-            <a:ext cx="1428750" cy="628650"/>
+            <a:ext cx="1619250" cy="628650"/>
           </a:xfrm>
           <a:prstGeom xmlns:a="http://schemas.openxmlformats.org/drawingml/2006/main" prst="roundRect">
             <a:avLst>
@@ -13021,7 +13021,7 @@
         <p:spPr>
           <a:xfrm xmlns:a="http://schemas.openxmlformats.org/drawingml/2006/main">
             <a:off x="3352800" y="3819525"/>
-            <a:ext cx="1238250" cy="238125"/>
+            <a:ext cx="1428750" cy="238125"/>
           </a:xfrm>
           <a:prstGeom xmlns:a="http://schemas.openxmlformats.org/drawingml/2006/main" prst="rect">
             <a:avLst/>
@@ -13079,8 +13079,8 @@
         </p:nvSpPr>
         <p:spPr>
           <a:xfrm xmlns:a="http://schemas.openxmlformats.org/drawingml/2006/main">
-            <a:off x="4686300" y="3619500"/>
-            <a:ext cx="1428750" cy="628650"/>
+            <a:off x="4876800" y="3619500"/>
+            <a:ext cx="1619250" cy="628650"/>
           </a:xfrm>
           <a:prstGeom xmlns:a="http://schemas.openxmlformats.org/drawingml/2006/main" prst="roundRect">
             <a:avLst>
@@ -13114,8 +13114,8 @@
         </p:nvSpPr>
         <p:spPr>
           <a:xfrm xmlns:a="http://schemas.openxmlformats.org/drawingml/2006/main">
-            <a:off x="4781550" y="3819525"/>
-            <a:ext cx="1238250" cy="238125"/>
+            <a:off x="4972050" y="3819525"/>
+            <a:ext cx="1428750" cy="238125"/>
           </a:xfrm>
           <a:prstGeom xmlns:a="http://schemas.openxmlformats.org/drawingml/2006/main" prst="rect">
             <a:avLst/>
@@ -13173,8 +13173,8 @@
         </p:nvSpPr>
         <p:spPr>
           <a:xfrm xmlns:a="http://schemas.openxmlformats.org/drawingml/2006/main">
-            <a:off x="6115050" y="3619500"/>
-            <a:ext cx="1428750" cy="628650"/>
+            <a:off x="6496050" y="3619500"/>
+            <a:ext cx="1619250" cy="628650"/>
           </a:xfrm>
           <a:prstGeom xmlns:a="http://schemas.openxmlformats.org/drawingml/2006/main" prst="roundRect">
             <a:avLst>
@@ -13208,8 +13208,8 @@
         </p:nvSpPr>
         <p:spPr>
           <a:xfrm xmlns:a="http://schemas.openxmlformats.org/drawingml/2006/main">
-            <a:off x="6210300" y="3819525"/>
-            <a:ext cx="1238250" cy="238125"/>
+            <a:off x="6591300" y="3819525"/>
+            <a:ext cx="1428750" cy="238125"/>
           </a:xfrm>
           <a:prstGeom xmlns:a="http://schemas.openxmlformats.org/drawingml/2006/main" prst="rect">
             <a:avLst/>
@@ -13267,8 +13267,8 @@
         </p:nvSpPr>
         <p:spPr>
           <a:xfrm xmlns:a="http://schemas.openxmlformats.org/drawingml/2006/main">
-            <a:off x="7543800" y="3619500"/>
-            <a:ext cx="1809750" cy="628650"/>
+            <a:off x="8115300" y="3619500"/>
+            <a:ext cx="2057400" cy="628650"/>
           </a:xfrm>
           <a:prstGeom xmlns:a="http://schemas.openxmlformats.org/drawingml/2006/main" prst="roundRect">
             <a:avLst>
@@ -13302,8 +13302,8 @@
         </p:nvSpPr>
         <p:spPr>
           <a:xfrm xmlns:a="http://schemas.openxmlformats.org/drawingml/2006/main">
-            <a:off x="7639050" y="3819525"/>
-            <a:ext cx="1619250" cy="238125"/>
+            <a:off x="8210550" y="3819525"/>
+            <a:ext cx="1866900" cy="238125"/>
           </a:xfrm>
           <a:prstGeom xmlns:a="http://schemas.openxmlformats.org/drawingml/2006/main" prst="rect">
             <a:avLst/>
@@ -13361,8 +13361,8 @@
         </p:nvSpPr>
         <p:spPr>
           <a:xfrm xmlns:a="http://schemas.openxmlformats.org/drawingml/2006/main">
-            <a:off x="9353550" y="3619500"/>
-            <a:ext cx="1428750" cy="628650"/>
+            <a:off x="10172700" y="3619500"/>
+            <a:ext cx="1619250" cy="628650"/>
           </a:xfrm>
           <a:prstGeom xmlns:a="http://schemas.openxmlformats.org/drawingml/2006/main" prst="roundRect">
             <a:avLst>
@@ -13396,8 +13396,8 @@
         </p:nvSpPr>
         <p:spPr>
           <a:xfrm xmlns:a="http://schemas.openxmlformats.org/drawingml/2006/main">
-            <a:off x="9448800" y="3819525"/>
-            <a:ext cx="1238250" cy="238125"/>
+            <a:off x="10267950" y="3819525"/>
+            <a:ext cx="1428750" cy="238125"/>
           </a:xfrm>
           <a:prstGeom xmlns:a="http://schemas.openxmlformats.org/drawingml/2006/main" prst="rect">
             <a:avLst/>
@@ -13548,7 +13548,7 @@
         <p:spPr>
           <a:xfrm xmlns:a="http://schemas.openxmlformats.org/drawingml/2006/main">
             <a:off x="3257550" y="4248150"/>
-            <a:ext cx="1428750" cy="628650"/>
+            <a:ext cx="1619250" cy="628650"/>
           </a:xfrm>
           <a:prstGeom xmlns:a="http://schemas.openxmlformats.org/drawingml/2006/main" prst="roundRect">
             <a:avLst>
@@ -13581,7 +13581,7 @@
         <p:spPr>
           <a:xfrm xmlns:a="http://schemas.openxmlformats.org/drawingml/2006/main">
             <a:off x="3352800" y="4448175"/>
-            <a:ext cx="1238250" cy="238125"/>
+            <a:ext cx="1428750" cy="238125"/>
           </a:xfrm>
           <a:prstGeom xmlns:a="http://schemas.openxmlformats.org/drawingml/2006/main" prst="rect">
             <a:avLst/>
@@ -13639,8 +13639,8 @@
         </p:nvSpPr>
         <p:spPr>
           <a:xfrm xmlns:a="http://schemas.openxmlformats.org/drawingml/2006/main">
-            <a:off x="4686300" y="4248150"/>
-            <a:ext cx="1428750" cy="628650"/>
+            <a:off x="4876800" y="4248150"/>
+            <a:ext cx="1619250" cy="628650"/>
           </a:xfrm>
           <a:prstGeom xmlns:a="http://schemas.openxmlformats.org/drawingml/2006/main" prst="roundRect">
             <a:avLst>
@@ -13672,8 +13672,8 @@
         </p:nvSpPr>
         <p:spPr>
           <a:xfrm xmlns:a="http://schemas.openxmlformats.org/drawingml/2006/main">
-            <a:off x="4781550" y="4448175"/>
-            <a:ext cx="1238250" cy="238125"/>
+            <a:off x="4972050" y="4448175"/>
+            <a:ext cx="1428750" cy="238125"/>
           </a:xfrm>
           <a:prstGeom xmlns:a="http://schemas.openxmlformats.org/drawingml/2006/main" prst="rect">
             <a:avLst/>
@@ -13731,8 +13731,8 @@
         </p:nvSpPr>
         <p:spPr>
           <a:xfrm xmlns:a="http://schemas.openxmlformats.org/drawingml/2006/main">
-            <a:off x="6115050" y="4248150"/>
-            <a:ext cx="1428750" cy="628650"/>
+            <a:off x="6496050" y="4248150"/>
+            <a:ext cx="1619250" cy="628650"/>
           </a:xfrm>
           <a:prstGeom xmlns:a="http://schemas.openxmlformats.org/drawingml/2006/main" prst="roundRect">
             <a:avLst>
@@ -13764,8 +13764,8 @@
         </p:nvSpPr>
         <p:spPr>
           <a:xfrm xmlns:a="http://schemas.openxmlformats.org/drawingml/2006/main">
-            <a:off x="6210300" y="4448175"/>
-            <a:ext cx="1238250" cy="238125"/>
+            <a:off x="6591300" y="4448175"/>
+            <a:ext cx="1428750" cy="238125"/>
           </a:xfrm>
           <a:prstGeom xmlns:a="http://schemas.openxmlformats.org/drawingml/2006/main" prst="rect">
             <a:avLst/>
@@ -13823,8 +13823,8 @@
         </p:nvSpPr>
         <p:spPr>
           <a:xfrm xmlns:a="http://schemas.openxmlformats.org/drawingml/2006/main">
-            <a:off x="7543800" y="4248150"/>
-            <a:ext cx="1809750" cy="628650"/>
+            <a:off x="8115300" y="4248150"/>
+            <a:ext cx="2057400" cy="628650"/>
           </a:xfrm>
           <a:prstGeom xmlns:a="http://schemas.openxmlformats.org/drawingml/2006/main" prst="roundRect">
             <a:avLst>
@@ -13856,8 +13856,8 @@
         </p:nvSpPr>
         <p:spPr>
           <a:xfrm xmlns:a="http://schemas.openxmlformats.org/drawingml/2006/main">
-            <a:off x="7639050" y="4448175"/>
-            <a:ext cx="1619250" cy="238125"/>
+            <a:off x="8210550" y="4448175"/>
+            <a:ext cx="1866900" cy="238125"/>
           </a:xfrm>
           <a:prstGeom xmlns:a="http://schemas.openxmlformats.org/drawingml/2006/main" prst="rect">
             <a:avLst/>
@@ -13915,8 +13915,8 @@
         </p:nvSpPr>
         <p:spPr>
           <a:xfrm xmlns:a="http://schemas.openxmlformats.org/drawingml/2006/main">
-            <a:off x="9353550" y="4248150"/>
-            <a:ext cx="1428750" cy="628650"/>
+            <a:off x="10172700" y="4248150"/>
+            <a:ext cx="1619250" cy="628650"/>
           </a:xfrm>
           <a:prstGeom xmlns:a="http://schemas.openxmlformats.org/drawingml/2006/main" prst="roundRect">
             <a:avLst>
@@ -13948,8 +13948,8 @@
         </p:nvSpPr>
         <p:spPr>
           <a:xfrm xmlns:a="http://schemas.openxmlformats.org/drawingml/2006/main">
-            <a:off x="9448800" y="4448175"/>
-            <a:ext cx="1238250" cy="238125"/>
+            <a:off x="10267950" y="4448175"/>
+            <a:ext cx="1428750" cy="238125"/>
           </a:xfrm>
           <a:prstGeom xmlns:a="http://schemas.openxmlformats.org/drawingml/2006/main" prst="rect">
             <a:avLst/>
@@ -14484,7 +14484,7 @@
           <p:nvPr/>
         </p:nvPicPr>
         <p:blipFill>
-          <a:blip xmlns:r="http://schemas.openxmlformats.org/officeDocument/2006/relationships" xmlns:a="http://schemas.openxmlformats.org/drawingml/2006/main" r:embed="Re775445b32fb4eb8"/>
+          <a:blip xmlns:r="http://schemas.openxmlformats.org/officeDocument/2006/relationships" xmlns:a="http://schemas.openxmlformats.org/drawingml/2006/main" r:embed="Rc7dbb6d769864434"/>
           <a:srcRect xmlns:a="http://schemas.openxmlformats.org/drawingml/2006/main" l="0" t="33403" r="0" b="33403"/>
           <a:stretch xmlns:a="http://schemas.openxmlformats.org/drawingml/2006/main">
             <a:fillRect l="0" t="0" r="0" b="0"/>
@@ -15426,8 +15426,8 @@
         </p:nvSpPr>
         <p:spPr>
           <a:xfrm xmlns:a="http://schemas.openxmlformats.org/drawingml/2006/main">
-            <a:off x="3676650" y="1447800"/>
-            <a:ext cx="8191500" cy="4705350"/>
+            <a:off x="3676650" y="1524000"/>
+            <a:ext cx="8191500" cy="4629150"/>
           </a:xfrm>
           <a:prstGeom xmlns:a="http://schemas.openxmlformats.org/drawingml/2006/main" prst="roundRect">
             <a:avLst>
@@ -15452,7 +15452,7 @@
           <p:nvPr/>
         </p:nvPicPr>
         <p:blipFill>
-          <a:blip xmlns:r="http://schemas.openxmlformats.org/officeDocument/2006/relationships" xmlns:a="http://schemas.openxmlformats.org/drawingml/2006/main" r:embed="Rffb087988b9f4222"/>
+          <a:blip xmlns:r="http://schemas.openxmlformats.org/officeDocument/2006/relationships" xmlns:a="http://schemas.openxmlformats.org/drawingml/2006/main" r:embed="R23f38c596c6c42a4"/>
           <a:srcRect xmlns:a="http://schemas.openxmlformats.org/drawingml/2006/main" l="0" t="29622" r="0" b="29622"/>
           <a:stretch xmlns:a="http://schemas.openxmlformats.org/drawingml/2006/main">
             <a:fillRect l="0" t="0" r="0" b="0"/>
@@ -15460,8 +15460,8 @@
         </p:blipFill>
         <p:spPr>
           <a:xfrm xmlns:a="http://schemas.openxmlformats.org/drawingml/2006/main">
-            <a:off x="3752850" y="1524000"/>
-            <a:ext cx="8039100" cy="4552950"/>
+            <a:off x="3752850" y="1600200"/>
+            <a:ext cx="8039100" cy="4476750"/>
           </a:xfrm>
           <a:prstGeom xmlns:a="http://schemas.openxmlformats.org/drawingml/2006/main" prst="rect">
             <a:avLst/>
@@ -16287,7 +16287,7 @@
           <p:nvPr/>
         </p:nvPicPr>
         <p:blipFill>
-          <a:blip xmlns:r="http://schemas.openxmlformats.org/officeDocument/2006/relationships" xmlns:a="http://schemas.openxmlformats.org/drawingml/2006/main" r:embed="Rb48bed6b7f7e47b6"/>
+          <a:blip xmlns:r="http://schemas.openxmlformats.org/officeDocument/2006/relationships" xmlns:a="http://schemas.openxmlformats.org/drawingml/2006/main" r:embed="Rf4d8b212e2014291"/>
           <a:srcRect xmlns:a="http://schemas.openxmlformats.org/drawingml/2006/main" l="0" t="46500" r="0" b="30636"/>
           <a:stretch xmlns:a="http://schemas.openxmlformats.org/drawingml/2006/main">
             <a:fillRect l="0" t="0" r="0" b="0"/>
@@ -17828,7 +17828,7 @@
         <p:spPr>
           <a:xfrm xmlns:a="http://schemas.openxmlformats.org/drawingml/2006/main">
             <a:off x="400050" y="1695450"/>
-            <a:ext cx="2038350" cy="2628900"/>
+            <a:ext cx="2076450" cy="2628900"/>
           </a:xfrm>
           <a:prstGeom xmlns:a="http://schemas.openxmlformats.org/drawingml/2006/main" prst="roundRect">
             <a:avLst>
@@ -17920,7 +17920,7 @@
         <p:spPr>
           <a:xfrm xmlns:a="http://schemas.openxmlformats.org/drawingml/2006/main">
             <a:off x="571500" y="2362200"/>
-            <a:ext cx="1695450" cy="533400"/>
+            <a:ext cx="1733550" cy="533400"/>
           </a:xfrm>
           <a:prstGeom xmlns:a="http://schemas.openxmlformats.org/drawingml/2006/main" prst="rect">
             <a:avLst/>
@@ -17979,7 +17979,7 @@
         <p:spPr>
           <a:xfrm xmlns:a="http://schemas.openxmlformats.org/drawingml/2006/main">
             <a:off x="571500" y="3105150"/>
-            <a:ext cx="1695450" cy="723900"/>
+            <a:ext cx="1733550" cy="723900"/>
           </a:xfrm>
           <a:prstGeom xmlns:a="http://schemas.openxmlformats.org/drawingml/2006/main" prst="rect">
             <a:avLst/>
@@ -18037,8 +18037,8 @@
         </p:nvSpPr>
         <p:spPr>
           <a:xfrm xmlns:a="http://schemas.openxmlformats.org/drawingml/2006/main">
-            <a:off x="2667000" y="1962150"/>
-            <a:ext cx="2038350" cy="2533650"/>
+            <a:off x="2728913" y="1962150"/>
+            <a:ext cx="2076450" cy="2533650"/>
           </a:xfrm>
           <a:prstGeom xmlns:a="http://schemas.openxmlformats.org/drawingml/2006/main" prst="roundRect">
             <a:avLst>
@@ -18070,7 +18070,7 @@
         </p:nvSpPr>
         <p:spPr>
           <a:xfrm xmlns:a="http://schemas.openxmlformats.org/drawingml/2006/main">
-            <a:off x="2838450" y="2152650"/>
+            <a:off x="2900363" y="2152650"/>
             <a:ext cx="419100" cy="228600"/>
           </a:xfrm>
           <a:prstGeom xmlns:a="http://schemas.openxmlformats.org/drawingml/2006/main" prst="rect">
@@ -18129,8 +18129,8 @@
         </p:nvSpPr>
         <p:spPr>
           <a:xfrm xmlns:a="http://schemas.openxmlformats.org/drawingml/2006/main">
-            <a:off x="2838450" y="2628900"/>
-            <a:ext cx="1695450" cy="533400"/>
+            <a:off x="2900363" y="2628900"/>
+            <a:ext cx="1733550" cy="533400"/>
           </a:xfrm>
           <a:prstGeom xmlns:a="http://schemas.openxmlformats.org/drawingml/2006/main" prst="rect">
             <a:avLst/>
@@ -18188,8 +18188,8 @@
         </p:nvSpPr>
         <p:spPr>
           <a:xfrm xmlns:a="http://schemas.openxmlformats.org/drawingml/2006/main">
-            <a:off x="2838450" y="3371850"/>
-            <a:ext cx="1695450" cy="723900"/>
+            <a:off x="2900363" y="3371850"/>
+            <a:ext cx="1733550" cy="723900"/>
           </a:xfrm>
           <a:prstGeom xmlns:a="http://schemas.openxmlformats.org/drawingml/2006/main" prst="rect">
             <a:avLst/>
@@ -18247,8 +18247,8 @@
         </p:nvSpPr>
         <p:spPr>
           <a:xfrm xmlns:a="http://schemas.openxmlformats.org/drawingml/2006/main">
-            <a:off x="4933950" y="2228850"/>
-            <a:ext cx="2038350" cy="2438400"/>
+            <a:off x="5057775" y="2228850"/>
+            <a:ext cx="2076450" cy="2438400"/>
           </a:xfrm>
           <a:prstGeom xmlns:a="http://schemas.openxmlformats.org/drawingml/2006/main" prst="roundRect">
             <a:avLst>
@@ -18280,7 +18280,7 @@
         </p:nvSpPr>
         <p:spPr>
           <a:xfrm xmlns:a="http://schemas.openxmlformats.org/drawingml/2006/main">
-            <a:off x="5105400" y="2419350"/>
+            <a:off x="5229225" y="2419350"/>
             <a:ext cx="419100" cy="228600"/>
           </a:xfrm>
           <a:prstGeom xmlns:a="http://schemas.openxmlformats.org/drawingml/2006/main" prst="rect">
@@ -18339,8 +18339,8 @@
         </p:nvSpPr>
         <p:spPr>
           <a:xfrm xmlns:a="http://schemas.openxmlformats.org/drawingml/2006/main">
-            <a:off x="5105400" y="2895600"/>
-            <a:ext cx="1695450" cy="533400"/>
+            <a:off x="5229225" y="2895600"/>
+            <a:ext cx="1733550" cy="533400"/>
           </a:xfrm>
           <a:prstGeom xmlns:a="http://schemas.openxmlformats.org/drawingml/2006/main" prst="rect">
             <a:avLst/>
@@ -18398,8 +18398,8 @@
         </p:nvSpPr>
         <p:spPr>
           <a:xfrm xmlns:a="http://schemas.openxmlformats.org/drawingml/2006/main">
-            <a:off x="5105400" y="3638550"/>
-            <a:ext cx="1695450" cy="723900"/>
+            <a:off x="5229225" y="3638550"/>
+            <a:ext cx="1733550" cy="723900"/>
           </a:xfrm>
           <a:prstGeom xmlns:a="http://schemas.openxmlformats.org/drawingml/2006/main" prst="rect">
             <a:avLst/>
@@ -18457,8 +18457,8 @@
         </p:nvSpPr>
         <p:spPr>
           <a:xfrm xmlns:a="http://schemas.openxmlformats.org/drawingml/2006/main">
-            <a:off x="7200900" y="2495550"/>
-            <a:ext cx="2038350" cy="2343150"/>
+            <a:off x="7386638" y="2495550"/>
+            <a:ext cx="2076450" cy="2343150"/>
           </a:xfrm>
           <a:prstGeom xmlns:a="http://schemas.openxmlformats.org/drawingml/2006/main" prst="roundRect">
             <a:avLst>
@@ -18490,7 +18490,7 @@
         </p:nvSpPr>
         <p:spPr>
           <a:xfrm xmlns:a="http://schemas.openxmlformats.org/drawingml/2006/main">
-            <a:off x="7372350" y="2686050"/>
+            <a:off x="7558088" y="2686050"/>
             <a:ext cx="419100" cy="228600"/>
           </a:xfrm>
           <a:prstGeom xmlns:a="http://schemas.openxmlformats.org/drawingml/2006/main" prst="rect">
@@ -18549,8 +18549,8 @@
         </p:nvSpPr>
         <p:spPr>
           <a:xfrm xmlns:a="http://schemas.openxmlformats.org/drawingml/2006/main">
-            <a:off x="7372350" y="3162300"/>
-            <a:ext cx="1695450" cy="533400"/>
+            <a:off x="7558088" y="3162300"/>
+            <a:ext cx="1733550" cy="533400"/>
           </a:xfrm>
           <a:prstGeom xmlns:a="http://schemas.openxmlformats.org/drawingml/2006/main" prst="rect">
             <a:avLst/>
@@ -18608,8 +18608,8 @@
         </p:nvSpPr>
         <p:spPr>
           <a:xfrm xmlns:a="http://schemas.openxmlformats.org/drawingml/2006/main">
-            <a:off x="7372350" y="3905250"/>
-            <a:ext cx="1695450" cy="723900"/>
+            <a:off x="7558088" y="3905250"/>
+            <a:ext cx="1733550" cy="723900"/>
           </a:xfrm>
           <a:prstGeom xmlns:a="http://schemas.openxmlformats.org/drawingml/2006/main" prst="rect">
             <a:avLst/>
@@ -18667,8 +18667,8 @@
         </p:nvSpPr>
         <p:spPr>
           <a:xfrm xmlns:a="http://schemas.openxmlformats.org/drawingml/2006/main">
-            <a:off x="9467850" y="2762250"/>
-            <a:ext cx="2038350" cy="2247900"/>
+            <a:off x="9715500" y="2762250"/>
+            <a:ext cx="2076450" cy="2247900"/>
           </a:xfrm>
           <a:prstGeom xmlns:a="http://schemas.openxmlformats.org/drawingml/2006/main" prst="roundRect">
             <a:avLst>
@@ -18700,7 +18700,7 @@
         </p:nvSpPr>
         <p:spPr>
           <a:xfrm xmlns:a="http://schemas.openxmlformats.org/drawingml/2006/main">
-            <a:off x="9639300" y="2952750"/>
+            <a:off x="9886950" y="2952750"/>
             <a:ext cx="419100" cy="228600"/>
           </a:xfrm>
           <a:prstGeom xmlns:a="http://schemas.openxmlformats.org/drawingml/2006/main" prst="rect">
@@ -18759,21 +18759,21 @@
         </p:nvSpPr>
         <p:spPr>
           <a:xfrm xmlns:a="http://schemas.openxmlformats.org/drawingml/2006/main">
-            <a:off x="9639300" y="3429000"/>
-            <a:ext cx="1695450" cy="533400"/>
-          </a:xfrm>
-          <a:prstGeom xmlns:a="http://schemas.openxmlformats.org/drawingml/2006/main" prst="rect">
-            <a:avLst/>
-          </a:prstGeom>
-          <a:noFill xmlns:a="http://schemas.openxmlformats.org/drawingml/2006/main"/>
-          <a:ln xmlns:a="http://schemas.openxmlformats.org/drawingml/2006/main" w="0">
-            <a:noFill/>
-            <a:prstDash val="solid"/>
-          </a:ln>
-        </p:spPr>
-        <p:txBody>
-          <a:bodyPr xmlns:a="http://schemas.openxmlformats.org/drawingml/2006/main" anchor="t">
-            <a:normAutofit fontScale="96667"/>
+            <a:off x="9886950" y="3429000"/>
+            <a:ext cx="1733550" cy="533400"/>
+          </a:xfrm>
+          <a:prstGeom xmlns:a="http://schemas.openxmlformats.org/drawingml/2006/main" prst="rect">
+            <a:avLst/>
+          </a:prstGeom>
+          <a:noFill xmlns:a="http://schemas.openxmlformats.org/drawingml/2006/main"/>
+          <a:ln xmlns:a="http://schemas.openxmlformats.org/drawingml/2006/main" w="0">
+            <a:noFill/>
+            <a:prstDash val="solid"/>
+          </a:ln>
+        </p:spPr>
+        <p:txBody>
+          <a:bodyPr xmlns:a="http://schemas.openxmlformats.org/drawingml/2006/main" anchor="t">
+            <a:normAutofit fontScale="98042"/>
           </a:bodyPr>
           <a:lstStyle xmlns:a="http://schemas.openxmlformats.org/drawingml/2006/main"/>
           <a:p xmlns:a="http://schemas.openxmlformats.org/drawingml/2006/main">
@@ -18818,8 +18818,8 @@
         </p:nvSpPr>
         <p:spPr>
           <a:xfrm xmlns:a="http://schemas.openxmlformats.org/drawingml/2006/main">
-            <a:off x="9639300" y="4171950"/>
-            <a:ext cx="1695450" cy="723900"/>
+            <a:off x="9886950" y="4171950"/>
+            <a:ext cx="1733550" cy="723900"/>
           </a:xfrm>
           <a:prstGeom xmlns:a="http://schemas.openxmlformats.org/drawingml/2006/main" prst="rect">
             <a:avLst/>

</xml_diff>

<commit_message>
design: update team attribution
</commit_message>
<xml_diff>
--- a/docs/submission/APAR_COMPETITION_DECK.pptx
+++ b/docs/submission/APAR_COMPETITION_DECK.pptx
@@ -2,23 +2,23 @@
 <file path=ppt/presentation.xml><?xml version="1.0" encoding="utf-8"?>
 <p:presentation xmlns:p="http://schemas.openxmlformats.org/presentationml/2006/main">
   <p:sldMasterIdLst>
-    <p:sldMasterId xmlns:r="http://schemas.openxmlformats.org/officeDocument/2006/relationships" id="2147483648" r:id="Rf043c89714ca4998"/>
+    <p:sldMasterId xmlns:r="http://schemas.openxmlformats.org/officeDocument/2006/relationships" id="2147483648" r:id="R8c7f2a85fb3944ec"/>
   </p:sldMasterIdLst>
   <p:notesMasterIdLst>
-    <p:notesMasterId xmlns:r="http://schemas.openxmlformats.org/officeDocument/2006/relationships" r:id="R50e4f95c92964fde"/>
+    <p:notesMasterId xmlns:r="http://schemas.openxmlformats.org/officeDocument/2006/relationships" r:id="Rb7efc0eb4f2140da"/>
   </p:notesMasterIdLst>
   <p:sldIdLst>
-    <p:sldId xmlns:r="http://schemas.openxmlformats.org/officeDocument/2006/relationships" id="256" r:id="R38706f60b2704d13"/>
-    <p:sldId xmlns:r="http://schemas.openxmlformats.org/officeDocument/2006/relationships" id="257" r:id="R4ed8a45f1b89410f"/>
-    <p:sldId xmlns:r="http://schemas.openxmlformats.org/officeDocument/2006/relationships" id="258" r:id="R7df392c0eb8846de"/>
-    <p:sldId xmlns:r="http://schemas.openxmlformats.org/officeDocument/2006/relationships" id="259" r:id="Re24c92aa8c2c4916"/>
-    <p:sldId xmlns:r="http://schemas.openxmlformats.org/officeDocument/2006/relationships" id="260" r:id="R7ebb08f8065f4497"/>
-    <p:sldId xmlns:r="http://schemas.openxmlformats.org/officeDocument/2006/relationships" id="261" r:id="Rdef3fb02294c4973"/>
-    <p:sldId xmlns:r="http://schemas.openxmlformats.org/officeDocument/2006/relationships" id="262" r:id="Rd66d7208b90e419a"/>
-    <p:sldId xmlns:r="http://schemas.openxmlformats.org/officeDocument/2006/relationships" id="263" r:id="R5df4f03cf9b44709"/>
-    <p:sldId xmlns:r="http://schemas.openxmlformats.org/officeDocument/2006/relationships" id="264" r:id="R53215c505acd4917"/>
-    <p:sldId xmlns:r="http://schemas.openxmlformats.org/officeDocument/2006/relationships" id="265" r:id="R190aa44d5c8148ec"/>
-    <p:sldId xmlns:r="http://schemas.openxmlformats.org/officeDocument/2006/relationships" id="266" r:id="R164edc439d5a4d65"/>
+    <p:sldId xmlns:r="http://schemas.openxmlformats.org/officeDocument/2006/relationships" id="256" r:id="R920775ac254944be"/>
+    <p:sldId xmlns:r="http://schemas.openxmlformats.org/officeDocument/2006/relationships" id="257" r:id="R95d2b26dfdcc4a57"/>
+    <p:sldId xmlns:r="http://schemas.openxmlformats.org/officeDocument/2006/relationships" id="258" r:id="R311f544cdb394752"/>
+    <p:sldId xmlns:r="http://schemas.openxmlformats.org/officeDocument/2006/relationships" id="259" r:id="R55f61da1313842a2"/>
+    <p:sldId xmlns:r="http://schemas.openxmlformats.org/officeDocument/2006/relationships" id="260" r:id="Rfb8cbbe325504b15"/>
+    <p:sldId xmlns:r="http://schemas.openxmlformats.org/officeDocument/2006/relationships" id="261" r:id="Rbe3bb513ec214ade"/>
+    <p:sldId xmlns:r="http://schemas.openxmlformats.org/officeDocument/2006/relationships" id="262" r:id="R3afe8a3f1b7a4820"/>
+    <p:sldId xmlns:r="http://schemas.openxmlformats.org/officeDocument/2006/relationships" id="263" r:id="R06f2e2e30bed4a52"/>
+    <p:sldId xmlns:r="http://schemas.openxmlformats.org/officeDocument/2006/relationships" id="264" r:id="R935d950247064033"/>
+    <p:sldId xmlns:r="http://schemas.openxmlformats.org/officeDocument/2006/relationships" id="265" r:id="Ra46eda8018ca44e4"/>
+    <p:sldId xmlns:r="http://schemas.openxmlformats.org/officeDocument/2006/relationships" id="266" r:id="Raa3d54c5740b4a96"/>
   </p:sldIdLst>
   <p:sldSz cx="12192000" cy="6858000"/>
   <p:notesSz cx="6858000" cy="9144000"/>
@@ -1520,7 +1520,7 @@
   </p:cSld>
   <p:clrMap bg1="lt1" tx1="dk1" bg2="lt2" tx2="dk2" accent1="accent1" accent2="accent2" accent3="accent3" accent4="accent4" accent5="accent5" accent6="accent6" hlink="hlink" folHlink="folHlink"/>
   <p:sldLayoutIdLst>
-    <p:sldLayoutId xmlns:r="http://schemas.openxmlformats.org/officeDocument/2006/relationships" id="2147483649" r:id="R65fcc1c9cd9f45aa"/>
+    <p:sldLayoutId xmlns:r="http://schemas.openxmlformats.org/officeDocument/2006/relationships" id="2147483649" r:id="R118f2f902b5c4c43"/>
   </p:sldLayoutIdLst>
   <p:txStyles>
     <p:titleStyle>
@@ -2415,7 +2415,18 @@
                 <a:ea typeface="Arial"/>
                 <a:cs typeface="Arial"/>
               </a:rPr>
-              <a:t>Dylan Moraes  •  Competition submission</a:t>
+              <a:t>Team: LedgerPe Labs</a:t>
+            </a:r>
+            <a:r>
+              <a:rPr sz="1050" b="0">
+                <a:solidFill>
+                  <a:srgbClr val="9C9183"/>
+                </a:solidFill>
+                <a:latin typeface="Arial"/>
+                <a:ea typeface="Arial"/>
+                <a:cs typeface="Arial"/>
+              </a:rPr>
+              <a:t>  •  Competition submission</a:t>
             </a:r>
           </a:p>
         </p:txBody>
@@ -2462,7 +2473,7 @@
           <p:nvPr/>
         </p:nvPicPr>
         <p:blipFill>
-          <a:blip xmlns:r="http://schemas.openxmlformats.org/officeDocument/2006/relationships" xmlns:a="http://schemas.openxmlformats.org/drawingml/2006/main" r:embed="R698f8ec12c554a1d"/>
+          <a:blip xmlns:r="http://schemas.openxmlformats.org/officeDocument/2006/relationships" xmlns:a="http://schemas.openxmlformats.org/drawingml/2006/main" r:embed="R69a758b9ab874a3c"/>
           <a:srcRect xmlns:a="http://schemas.openxmlformats.org/drawingml/2006/main" l="0" t="0" r="0" b="32694"/>
           <a:stretch xmlns:a="http://schemas.openxmlformats.org/drawingml/2006/main">
             <a:fillRect l="0" t="0" r="0" b="0"/>
@@ -5992,7 +6003,18 @@
                 <a:ea typeface="Menlo"/>
                 <a:cs typeface="Menlo"/>
               </a:rPr>
-              <a:t>Adaptive Payment Assurance Range  •  Dylan Moraes</a:t>
+              <a:t>Adaptive Payment Assurance Range  •  </a:t>
+            </a:r>
+            <a:r>
+              <a:rPr sz="825" b="0">
+                <a:solidFill>
+                  <a:srgbClr val="9C9183"/>
+                </a:solidFill>
+                <a:latin typeface="Menlo"/>
+                <a:ea typeface="Menlo"/>
+                <a:cs typeface="Menlo"/>
+              </a:rPr>
+              <a:t>Team: LedgerPe Labs</a:t>
             </a:r>
           </a:p>
         </p:txBody>
@@ -14484,7 +14506,7 @@
           <p:nvPr/>
         </p:nvPicPr>
         <p:blipFill>
-          <a:blip xmlns:r="http://schemas.openxmlformats.org/officeDocument/2006/relationships" xmlns:a="http://schemas.openxmlformats.org/drawingml/2006/main" r:embed="Rc7dbb6d769864434"/>
+          <a:blip xmlns:r="http://schemas.openxmlformats.org/officeDocument/2006/relationships" xmlns:a="http://schemas.openxmlformats.org/drawingml/2006/main" r:embed="R00864de50fae4e5d"/>
           <a:srcRect xmlns:a="http://schemas.openxmlformats.org/drawingml/2006/main" l="0" t="33403" r="0" b="33403"/>
           <a:stretch xmlns:a="http://schemas.openxmlformats.org/drawingml/2006/main">
             <a:fillRect l="0" t="0" r="0" b="0"/>
@@ -15452,7 +15474,7 @@
           <p:nvPr/>
         </p:nvPicPr>
         <p:blipFill>
-          <a:blip xmlns:r="http://schemas.openxmlformats.org/officeDocument/2006/relationships" xmlns:a="http://schemas.openxmlformats.org/drawingml/2006/main" r:embed="R23f38c596c6c42a4"/>
+          <a:blip xmlns:r="http://schemas.openxmlformats.org/officeDocument/2006/relationships" xmlns:a="http://schemas.openxmlformats.org/drawingml/2006/main" r:embed="R9382e78b8b1541bf"/>
           <a:srcRect xmlns:a="http://schemas.openxmlformats.org/drawingml/2006/main" l="0" t="29622" r="0" b="29622"/>
           <a:stretch xmlns:a="http://schemas.openxmlformats.org/drawingml/2006/main">
             <a:fillRect l="0" t="0" r="0" b="0"/>
@@ -16287,7 +16309,7 @@
           <p:nvPr/>
         </p:nvPicPr>
         <p:blipFill>
-          <a:blip xmlns:r="http://schemas.openxmlformats.org/officeDocument/2006/relationships" xmlns:a="http://schemas.openxmlformats.org/drawingml/2006/main" r:embed="Rf4d8b212e2014291"/>
+          <a:blip xmlns:r="http://schemas.openxmlformats.org/officeDocument/2006/relationships" xmlns:a="http://schemas.openxmlformats.org/drawingml/2006/main" r:embed="Rb69b8c48dc214f3d"/>
           <a:srcRect xmlns:a="http://schemas.openxmlformats.org/drawingml/2006/main" l="0" t="46500" r="0" b="30636"/>
           <a:stretch xmlns:a="http://schemas.openxmlformats.org/drawingml/2006/main">
             <a:fillRect l="0" t="0" r="0" b="0"/>

</xml_diff>